<commit_message>
Replay screenshots retaken from the live deployment; report and slides rebuilt
The deployed Replay tab now shows the 'review written' column and counts the
reviews written before the parcel arrived (4 of the 8 hits on 16 July 2018).
The report figure, docs/screenshots and the slide 9 screenshot are taken from
https://team10-it5006-olist.streamlit.app after the redeploy.
</commit_message>
<xml_diff>
--- a/docs/Team10_Phase3_slides.pptx
+++ b/docs/Team10_Phase3_slides.pptx
@@ -199,7 +199,7 @@
             <c:bubble3D val="0"/>
             <c:extLst>
               <c:ext xmlns:c16="http://schemas.microsoft.com/office/drawing/2014/chart" uri="{C3380CC4-5D6E-409C-BE32-E72D297353CC}">
-                <c16:uniqueId val="{00000001-00A1-43BD-94C2-31B305D2F652}"/>
+                <c16:uniqueId val="{00000001-C3C3-4350-AAB1-2820CDB871BA}"/>
               </c:ext>
             </c:extLst>
           </c:dPt>
@@ -209,7 +209,7 @@
             <c:bubble3D val="0"/>
             <c:extLst>
               <c:ext xmlns:c16="http://schemas.microsoft.com/office/drawing/2014/chart" uri="{C3380CC4-5D6E-409C-BE32-E72D297353CC}">
-                <c16:uniqueId val="{00000003-00A1-43BD-94C2-31B305D2F652}"/>
+                <c16:uniqueId val="{00000003-C3C3-4350-AAB1-2820CDB871BA}"/>
               </c:ext>
             </c:extLst>
           </c:dPt>
@@ -219,7 +219,7 @@
             <c:bubble3D val="0"/>
             <c:extLst>
               <c:ext xmlns:c16="http://schemas.microsoft.com/office/drawing/2014/chart" uri="{C3380CC4-5D6E-409C-BE32-E72D297353CC}">
-                <c16:uniqueId val="{00000005-00A1-43BD-94C2-31B305D2F652}"/>
+                <c16:uniqueId val="{00000005-C3C3-4350-AAB1-2820CDB871BA}"/>
               </c:ext>
             </c:extLst>
           </c:dPt>
@@ -229,7 +229,7 @@
             <c:bubble3D val="0"/>
             <c:extLst>
               <c:ext xmlns:c16="http://schemas.microsoft.com/office/drawing/2014/chart" uri="{C3380CC4-5D6E-409C-BE32-E72D297353CC}">
-                <c16:uniqueId val="{00000007-00A1-43BD-94C2-31B305D2F652}"/>
+                <c16:uniqueId val="{00000007-C3C3-4350-AAB1-2820CDB871BA}"/>
               </c:ext>
             </c:extLst>
           </c:dPt>
@@ -239,7 +239,7 @@
             <c:bubble3D val="0"/>
             <c:extLst>
               <c:ext xmlns:c16="http://schemas.microsoft.com/office/drawing/2014/chart" uri="{C3380CC4-5D6E-409C-BE32-E72D297353CC}">
-                <c16:uniqueId val="{00000009-00A1-43BD-94C2-31B305D2F652}"/>
+                <c16:uniqueId val="{00000009-C3C3-4350-AAB1-2820CDB871BA}"/>
               </c:ext>
             </c:extLst>
           </c:dPt>
@@ -249,7 +249,7 @@
             <c:bubble3D val="0"/>
             <c:extLst>
               <c:ext xmlns:c16="http://schemas.microsoft.com/office/drawing/2014/chart" uri="{C3380CC4-5D6E-409C-BE32-E72D297353CC}">
-                <c16:uniqueId val="{0000000B-00A1-43BD-94C2-31B305D2F652}"/>
+                <c16:uniqueId val="{0000000B-C3C3-4350-AAB1-2820CDB871BA}"/>
               </c:ext>
             </c:extLst>
           </c:dPt>
@@ -259,7 +259,7 @@
             <c:bubble3D val="0"/>
             <c:extLst>
               <c:ext xmlns:c16="http://schemas.microsoft.com/office/drawing/2014/chart" uri="{C3380CC4-5D6E-409C-BE32-E72D297353CC}">
-                <c16:uniqueId val="{0000000D-00A1-43BD-94C2-31B305D2F652}"/>
+                <c16:uniqueId val="{0000000D-C3C3-4350-AAB1-2820CDB871BA}"/>
               </c:ext>
             </c:extLst>
           </c:dPt>
@@ -269,7 +269,7 @@
             <c:bubble3D val="0"/>
             <c:extLst>
               <c:ext xmlns:c16="http://schemas.microsoft.com/office/drawing/2014/chart" uri="{C3380CC4-5D6E-409C-BE32-E72D297353CC}">
-                <c16:uniqueId val="{0000000F-00A1-43BD-94C2-31B305D2F652}"/>
+                <c16:uniqueId val="{0000000F-C3C3-4350-AAB1-2820CDB871BA}"/>
               </c:ext>
             </c:extLst>
           </c:dPt>
@@ -279,7 +279,7 @@
             <c:bubble3D val="0"/>
             <c:extLst>
               <c:ext xmlns:c16="http://schemas.microsoft.com/office/drawing/2014/chart" uri="{C3380CC4-5D6E-409C-BE32-E72D297353CC}">
-                <c16:uniqueId val="{00000011-00A1-43BD-94C2-31B305D2F652}"/>
+                <c16:uniqueId val="{00000011-C3C3-4350-AAB1-2820CDB871BA}"/>
               </c:ext>
             </c:extLst>
           </c:dPt>
@@ -289,7 +289,7 @@
             <c:bubble3D val="0"/>
             <c:extLst>
               <c:ext xmlns:c16="http://schemas.microsoft.com/office/drawing/2014/chart" uri="{C3380CC4-5D6E-409C-BE32-E72D297353CC}">
-                <c16:uniqueId val="{00000013-00A1-43BD-94C2-31B305D2F652}"/>
+                <c16:uniqueId val="{00000013-C3C3-4350-AAB1-2820CDB871BA}"/>
               </c:ext>
             </c:extLst>
           </c:dPt>
@@ -305,7 +305,7 @@
             </c:spPr>
             <c:extLst>
               <c:ext xmlns:c16="http://schemas.microsoft.com/office/drawing/2014/chart" uri="{C3380CC4-5D6E-409C-BE32-E72D297353CC}">
-                <c16:uniqueId val="{00000015-00A1-43BD-94C2-31B305D2F652}"/>
+                <c16:uniqueId val="{00000015-C3C3-4350-AAB1-2820CDB871BA}"/>
               </c:ext>
             </c:extLst>
           </c:dPt>
@@ -315,7 +315,7 @@
             <c:bubble3D val="0"/>
             <c:extLst>
               <c:ext xmlns:c16="http://schemas.microsoft.com/office/drawing/2014/chart" uri="{C3380CC4-5D6E-409C-BE32-E72D297353CC}">
-                <c16:uniqueId val="{00000017-00A1-43BD-94C2-31B305D2F652}"/>
+                <c16:uniqueId val="{00000017-C3C3-4350-AAB1-2820CDB871BA}"/>
               </c:ext>
             </c:extLst>
           </c:dPt>
@@ -325,7 +325,7 @@
             <c:bubble3D val="0"/>
             <c:extLst>
               <c:ext xmlns:c16="http://schemas.microsoft.com/office/drawing/2014/chart" uri="{C3380CC4-5D6E-409C-BE32-E72D297353CC}">
-                <c16:uniqueId val="{00000019-00A1-43BD-94C2-31B305D2F652}"/>
+                <c16:uniqueId val="{00000019-C3C3-4350-AAB1-2820CDB871BA}"/>
               </c:ext>
             </c:extLst>
           </c:dPt>
@@ -341,7 +341,7 @@
             </c:spPr>
             <c:extLst>
               <c:ext xmlns:c16="http://schemas.microsoft.com/office/drawing/2014/chart" uri="{C3380CC4-5D6E-409C-BE32-E72D297353CC}">
-                <c16:uniqueId val="{0000001B-00A1-43BD-94C2-31B305D2F652}"/>
+                <c16:uniqueId val="{0000001B-C3C3-4350-AAB1-2820CDB871BA}"/>
               </c:ext>
             </c:extLst>
           </c:dPt>
@@ -357,7 +357,7 @@
             </c:spPr>
             <c:extLst>
               <c:ext xmlns:c16="http://schemas.microsoft.com/office/drawing/2014/chart" uri="{C3380CC4-5D6E-409C-BE32-E72D297353CC}">
-                <c16:uniqueId val="{0000001D-00A1-43BD-94C2-31B305D2F652}"/>
+                <c16:uniqueId val="{0000001D-C3C3-4350-AAB1-2820CDB871BA}"/>
               </c:ext>
             </c:extLst>
           </c:dPt>
@@ -367,7 +367,7 @@
             <c:bubble3D val="0"/>
             <c:extLst>
               <c:ext xmlns:c16="http://schemas.microsoft.com/office/drawing/2014/chart" uri="{C3380CC4-5D6E-409C-BE32-E72D297353CC}">
-                <c16:uniqueId val="{0000001F-00A1-43BD-94C2-31B305D2F652}"/>
+                <c16:uniqueId val="{0000001F-C3C3-4350-AAB1-2820CDB871BA}"/>
               </c:ext>
             </c:extLst>
           </c:dPt>
@@ -377,7 +377,7 @@
             <c:bubble3D val="0"/>
             <c:extLst>
               <c:ext xmlns:c16="http://schemas.microsoft.com/office/drawing/2014/chart" uri="{C3380CC4-5D6E-409C-BE32-E72D297353CC}">
-                <c16:uniqueId val="{00000021-00A1-43BD-94C2-31B305D2F652}"/>
+                <c16:uniqueId val="{00000021-C3C3-4350-AAB1-2820CDB871BA}"/>
               </c:ext>
             </c:extLst>
           </c:dPt>
@@ -393,7 +393,7 @@
             </c:spPr>
             <c:extLst>
               <c:ext xmlns:c16="http://schemas.microsoft.com/office/drawing/2014/chart" uri="{C3380CC4-5D6E-409C-BE32-E72D297353CC}">
-                <c16:uniqueId val="{00000023-00A1-43BD-94C2-31B305D2F652}"/>
+                <c16:uniqueId val="{00000023-C3C3-4350-AAB1-2820CDB871BA}"/>
               </c:ext>
             </c:extLst>
           </c:dPt>
@@ -403,7 +403,7 @@
             <c:bubble3D val="0"/>
             <c:extLst>
               <c:ext xmlns:c16="http://schemas.microsoft.com/office/drawing/2014/chart" uri="{C3380CC4-5D6E-409C-BE32-E72D297353CC}">
-                <c16:uniqueId val="{00000025-00A1-43BD-94C2-31B305D2F652}"/>
+                <c16:uniqueId val="{00000025-C3C3-4350-AAB1-2820CDB871BA}"/>
               </c:ext>
             </c:extLst>
           </c:dPt>
@@ -413,7 +413,7 @@
             <c:bubble3D val="0"/>
             <c:extLst>
               <c:ext xmlns:c16="http://schemas.microsoft.com/office/drawing/2014/chart" uri="{C3380CC4-5D6E-409C-BE32-E72D297353CC}">
-                <c16:uniqueId val="{00000027-00A1-43BD-94C2-31B305D2F652}"/>
+                <c16:uniqueId val="{00000027-C3C3-4350-AAB1-2820CDB871BA}"/>
               </c:ext>
             </c:extLst>
           </c:dPt>
@@ -556,7 +556,7 @@
           </c:val>
           <c:extLst>
             <c:ext xmlns:c16="http://schemas.microsoft.com/office/drawing/2014/chart" uri="{C3380CC4-5D6E-409C-BE32-E72D297353CC}">
-              <c16:uniqueId val="{00000028-00A1-43BD-94C2-31B305D2F652}"/>
+              <c16:uniqueId val="{00000028-C3C3-4350-AAB1-2820CDB871BA}"/>
             </c:ext>
           </c:extLst>
         </c:ser>
@@ -729,7 +729,7 @@
             <c:bubble3D val="0"/>
             <c:extLst>
               <c:ext xmlns:c16="http://schemas.microsoft.com/office/drawing/2014/chart" uri="{C3380CC4-5D6E-409C-BE32-E72D297353CC}">
-                <c16:uniqueId val="{00000001-F7BC-427E-A37F-DFA0883321E6}"/>
+                <c16:uniqueId val="{00000001-8A97-412E-AE60-BAC0811420D0}"/>
               </c:ext>
             </c:extLst>
           </c:dPt>
@@ -739,7 +739,7 @@
             <c:bubble3D val="0"/>
             <c:extLst>
               <c:ext xmlns:c16="http://schemas.microsoft.com/office/drawing/2014/chart" uri="{C3380CC4-5D6E-409C-BE32-E72D297353CC}">
-                <c16:uniqueId val="{00000003-F7BC-427E-A37F-DFA0883321E6}"/>
+                <c16:uniqueId val="{00000003-8A97-412E-AE60-BAC0811420D0}"/>
               </c:ext>
             </c:extLst>
           </c:dPt>
@@ -755,7 +755,7 @@
             </c:spPr>
             <c:extLst>
               <c:ext xmlns:c16="http://schemas.microsoft.com/office/drawing/2014/chart" uri="{C3380CC4-5D6E-409C-BE32-E72D297353CC}">
-                <c16:uniqueId val="{00000005-F7BC-427E-A37F-DFA0883321E6}"/>
+                <c16:uniqueId val="{00000005-8A97-412E-AE60-BAC0811420D0}"/>
               </c:ext>
             </c:extLst>
           </c:dPt>
@@ -771,7 +771,7 @@
             </c:spPr>
             <c:extLst>
               <c:ext xmlns:c16="http://schemas.microsoft.com/office/drawing/2014/chart" uri="{C3380CC4-5D6E-409C-BE32-E72D297353CC}">
-                <c16:uniqueId val="{00000007-F7BC-427E-A37F-DFA0883321E6}"/>
+                <c16:uniqueId val="{00000007-8A97-412E-AE60-BAC0811420D0}"/>
               </c:ext>
             </c:extLst>
           </c:dPt>
@@ -787,7 +787,7 @@
             </c:spPr>
             <c:extLst>
               <c:ext xmlns:c16="http://schemas.microsoft.com/office/drawing/2014/chart" uri="{C3380CC4-5D6E-409C-BE32-E72D297353CC}">
-                <c16:uniqueId val="{00000009-F7BC-427E-A37F-DFA0883321E6}"/>
+                <c16:uniqueId val="{00000009-8A97-412E-AE60-BAC0811420D0}"/>
               </c:ext>
             </c:extLst>
           </c:dPt>
@@ -803,7 +803,7 @@
             </c:spPr>
             <c:extLst>
               <c:ext xmlns:c16="http://schemas.microsoft.com/office/drawing/2014/chart" uri="{C3380CC4-5D6E-409C-BE32-E72D297353CC}">
-                <c16:uniqueId val="{0000000B-F7BC-427E-A37F-DFA0883321E6}"/>
+                <c16:uniqueId val="{0000000B-8A97-412E-AE60-BAC0811420D0}"/>
               </c:ext>
             </c:extLst>
           </c:dPt>
@@ -819,7 +819,7 @@
             </c:spPr>
             <c:extLst>
               <c:ext xmlns:c16="http://schemas.microsoft.com/office/drawing/2014/chart" uri="{C3380CC4-5D6E-409C-BE32-E72D297353CC}">
-                <c16:uniqueId val="{0000000D-F7BC-427E-A37F-DFA0883321E6}"/>
+                <c16:uniqueId val="{0000000D-8A97-412E-AE60-BAC0811420D0}"/>
               </c:ext>
             </c:extLst>
           </c:dPt>
@@ -835,7 +835,7 @@
             </c:spPr>
             <c:extLst>
               <c:ext xmlns:c16="http://schemas.microsoft.com/office/drawing/2014/chart" uri="{C3380CC4-5D6E-409C-BE32-E72D297353CC}">
-                <c16:uniqueId val="{0000000F-F7BC-427E-A37F-DFA0883321E6}"/>
+                <c16:uniqueId val="{0000000F-8A97-412E-AE60-BAC0811420D0}"/>
               </c:ext>
             </c:extLst>
           </c:dPt>
@@ -851,7 +851,7 @@
             </c:spPr>
             <c:extLst>
               <c:ext xmlns:c16="http://schemas.microsoft.com/office/drawing/2014/chart" uri="{C3380CC4-5D6E-409C-BE32-E72D297353CC}">
-                <c16:uniqueId val="{00000011-F7BC-427E-A37F-DFA0883321E6}"/>
+                <c16:uniqueId val="{00000011-8A97-412E-AE60-BAC0811420D0}"/>
               </c:ext>
             </c:extLst>
           </c:dPt>
@@ -965,7 +965,7 @@
           </c:val>
           <c:extLst>
             <c:ext xmlns:c16="http://schemas.microsoft.com/office/drawing/2014/chart" uri="{C3380CC4-5D6E-409C-BE32-E72D297353CC}">
-              <c16:uniqueId val="{00000012-F7BC-427E-A37F-DFA0883321E6}"/>
+              <c16:uniqueId val="{00000012-8A97-412E-AE60-BAC0811420D0}"/>
             </c:ext>
           </c:extLst>
         </c:ser>
@@ -1209,7 +1209,7 @@
           <c:smooth val="0"/>
           <c:extLst>
             <c:ext xmlns:c16="http://schemas.microsoft.com/office/drawing/2014/chart" uri="{C3380CC4-5D6E-409C-BE32-E72D297353CC}">
-              <c16:uniqueId val="{00000000-03F1-4B82-B868-B41D032CCD05}"/>
+              <c16:uniqueId val="{00000000-49E8-4C68-9C56-5F4508731443}"/>
             </c:ext>
           </c:extLst>
         </c:ser>
@@ -1346,7 +1346,7 @@
           <c:smooth val="0"/>
           <c:extLst>
             <c:ext xmlns:c16="http://schemas.microsoft.com/office/drawing/2014/chart" uri="{C3380CC4-5D6E-409C-BE32-E72D297353CC}">
-              <c16:uniqueId val="{00000001-03F1-4B82-B868-B41D032CCD05}"/>
+              <c16:uniqueId val="{00000001-49E8-4C68-9C56-5F4508731443}"/>
             </c:ext>
           </c:extLst>
         </c:ser>
@@ -1552,7 +1552,7 @@
     </p:spTree>
     <p:extLst>
       <p:ext uri="{BB962C8B-B14F-4D97-AF65-F5344CB8AC3E}">
-        <p14:creationId xmlns:p14="http://schemas.microsoft.com/office/powerpoint/2010/main" val="3207210252"/>
+        <p14:creationId xmlns:p14="http://schemas.microsoft.com/office/powerpoint/2010/main" val="1501845788"/>
       </p:ext>
     </p:extLst>
   </p:cSld>
@@ -4481,7 +4481,7 @@
           <p:cNvPr id="25" name="s1 people">
             <a:extLst>
               <a:ext uri="{FF2B5EF4-FFF2-40B4-BE49-F238E27FC236}">
-                <a16:creationId xmlns:a16="http://schemas.microsoft.com/office/drawing/2014/main" id="{BCE25250-0705-3466-4AFB-394DE7299453}"/>
+                <a16:creationId xmlns:a16="http://schemas.microsoft.com/office/drawing/2014/main" id="{8D4294CE-0EC5-1CB5-3AD5-933DB84CEE5B}"/>
               </a:ext>
             </a:extLst>
           </p:cNvPr>
@@ -4580,7 +4580,7 @@
           <p:cNvPr id="26" name="s1 qr">
             <a:extLst>
               <a:ext uri="{FF2B5EF4-FFF2-40B4-BE49-F238E27FC236}">
-                <a16:creationId xmlns:a16="http://schemas.microsoft.com/office/drawing/2014/main" id="{F6475FE3-223A-0967-ABB7-233CFE796ADB}"/>
+                <a16:creationId xmlns:a16="http://schemas.microsoft.com/office/drawing/2014/main" id="{4E9234B5-85D3-4134-3558-3724503D9622}"/>
               </a:ext>
             </a:extLst>
           </p:cNvPr>
@@ -6229,7 +6229,7 @@
           <p:cNvPr id="45" name="s10 card0">
             <a:extLst>
               <a:ext uri="{FF2B5EF4-FFF2-40B4-BE49-F238E27FC236}">
-                <a16:creationId xmlns:a16="http://schemas.microsoft.com/office/drawing/2014/main" id="{0A189A8C-A8D0-ADD1-09AF-4364ED51209C}"/>
+                <a16:creationId xmlns:a16="http://schemas.microsoft.com/office/drawing/2014/main" id="{45DC62A8-5C5C-DE2A-F0BD-EF28617EE244}"/>
               </a:ext>
             </a:extLst>
           </p:cNvPr>
@@ -6447,7 +6447,7 @@
           <p:cNvPr id="46" name="s10 card1">
             <a:extLst>
               <a:ext uri="{FF2B5EF4-FFF2-40B4-BE49-F238E27FC236}">
-                <a16:creationId xmlns:a16="http://schemas.microsoft.com/office/drawing/2014/main" id="{6BFF01AB-56E7-10C8-58BD-ACCBA86E3270}"/>
+                <a16:creationId xmlns:a16="http://schemas.microsoft.com/office/drawing/2014/main" id="{8C17C7AC-DB7E-8A25-E9E1-D9496F0B41BA}"/>
               </a:ext>
             </a:extLst>
           </p:cNvPr>
@@ -6665,7 +6665,7 @@
           <p:cNvPr id="47" name="s10 card2">
             <a:extLst>
               <a:ext uri="{FF2B5EF4-FFF2-40B4-BE49-F238E27FC236}">
-                <a16:creationId xmlns:a16="http://schemas.microsoft.com/office/drawing/2014/main" id="{A5AA4D78-D73F-6794-9B3E-477A6AFAE502}"/>
+                <a16:creationId xmlns:a16="http://schemas.microsoft.com/office/drawing/2014/main" id="{CD9E75F4-A9B5-B7E1-42E3-BEF9FCE7F558}"/>
               </a:ext>
             </a:extLst>
           </p:cNvPr>
@@ -6883,7 +6883,7 @@
           <p:cNvPr id="48" name="s10 card3">
             <a:extLst>
               <a:ext uri="{FF2B5EF4-FFF2-40B4-BE49-F238E27FC236}">
-                <a16:creationId xmlns:a16="http://schemas.microsoft.com/office/drawing/2014/main" id="{9CC51FA2-1419-1260-2BB8-D818A0EA741A}"/>
+                <a16:creationId xmlns:a16="http://schemas.microsoft.com/office/drawing/2014/main" id="{E0CE06A9-759B-A144-12F2-85DEDA87A5A0}"/>
               </a:ext>
             </a:extLst>
           </p:cNvPr>
@@ -8207,7 +8207,7 @@
           <p:cNvPr id="69" name="s11 tileA">
             <a:extLst>
               <a:ext uri="{FF2B5EF4-FFF2-40B4-BE49-F238E27FC236}">
-                <a16:creationId xmlns:a16="http://schemas.microsoft.com/office/drawing/2014/main" id="{48C77CFE-8618-9BC0-1064-18314FF073E4}"/>
+                <a16:creationId xmlns:a16="http://schemas.microsoft.com/office/drawing/2014/main" id="{4F5AA925-E533-2C4C-5DE3-6C9FF9D464EF}"/>
               </a:ext>
             </a:extLst>
           </p:cNvPr>
@@ -8374,7 +8374,7 @@
           <p:cNvPr id="70" name="s11 tileB">
             <a:extLst>
               <a:ext uri="{FF2B5EF4-FFF2-40B4-BE49-F238E27FC236}">
-                <a16:creationId xmlns:a16="http://schemas.microsoft.com/office/drawing/2014/main" id="{AD5D1618-3560-66FF-1893-98CF256681E3}"/>
+                <a16:creationId xmlns:a16="http://schemas.microsoft.com/office/drawing/2014/main" id="{480F1C02-254C-878F-EB27-B1D597715C1D}"/>
               </a:ext>
             </a:extLst>
           </p:cNvPr>
@@ -8541,7 +8541,7 @@
           <p:cNvPr id="71" name="s11 panel">
             <a:extLst>
               <a:ext uri="{FF2B5EF4-FFF2-40B4-BE49-F238E27FC236}">
-                <a16:creationId xmlns:a16="http://schemas.microsoft.com/office/drawing/2014/main" id="{7052915B-B13D-E953-CD83-DD61EB313FD7}"/>
+                <a16:creationId xmlns:a16="http://schemas.microsoft.com/office/drawing/2014/main" id="{4BA0C9AA-4D76-3761-B5B3-F9966369E5D6}"/>
               </a:ext>
             </a:extLst>
           </p:cNvPr>
@@ -8630,7 +8630,7 @@
           <p:cNvPr id="72" name="s11 step1">
             <a:extLst>
               <a:ext uri="{FF2B5EF4-FFF2-40B4-BE49-F238E27FC236}">
-                <a16:creationId xmlns:a16="http://schemas.microsoft.com/office/drawing/2014/main" id="{78BCA24C-78F6-21FD-03BE-2FF0A9B86389}"/>
+                <a16:creationId xmlns:a16="http://schemas.microsoft.com/office/drawing/2014/main" id="{913CA773-5452-EB07-3581-4C338E1279DC}"/>
               </a:ext>
             </a:extLst>
           </p:cNvPr>
@@ -9180,7 +9180,7 @@
           <p:cNvPr id="73" name="s11 step2">
             <a:extLst>
               <a:ext uri="{FF2B5EF4-FFF2-40B4-BE49-F238E27FC236}">
-                <a16:creationId xmlns:a16="http://schemas.microsoft.com/office/drawing/2014/main" id="{65303E80-2792-F795-6726-A5754C343424}"/>
+                <a16:creationId xmlns:a16="http://schemas.microsoft.com/office/drawing/2014/main" id="{8B119E44-E80E-E80F-2E37-D819974C9BBF}"/>
               </a:ext>
             </a:extLst>
           </p:cNvPr>
@@ -9474,7 +9474,7 @@
           <p:cNvPr id="74" name="s11 step3">
             <a:extLst>
               <a:ext uri="{FF2B5EF4-FFF2-40B4-BE49-F238E27FC236}">
-                <a16:creationId xmlns:a16="http://schemas.microsoft.com/office/drawing/2014/main" id="{3BA9E3F2-E7BD-A6C7-54DE-F672C0CD01E3}"/>
+                <a16:creationId xmlns:a16="http://schemas.microsoft.com/office/drawing/2014/main" id="{C3747A8A-898B-C317-BF39-C714D98E6FC0}"/>
               </a:ext>
             </a:extLst>
           </p:cNvPr>
@@ -11035,7 +11035,7 @@
           <p:cNvPr id="37" name="s12 lesson0">
             <a:extLst>
               <a:ext uri="{FF2B5EF4-FFF2-40B4-BE49-F238E27FC236}">
-                <a16:creationId xmlns:a16="http://schemas.microsoft.com/office/drawing/2014/main" id="{4CB66498-A68A-12E6-2E7F-A636EA8EB4F9}"/>
+                <a16:creationId xmlns:a16="http://schemas.microsoft.com/office/drawing/2014/main" id="{77737B05-EF20-B7DA-7B19-372568F23CFB}"/>
               </a:ext>
             </a:extLst>
           </p:cNvPr>
@@ -11227,7 +11227,7 @@
           <p:cNvPr id="38" name="s12 lesson1">
             <a:extLst>
               <a:ext uri="{FF2B5EF4-FFF2-40B4-BE49-F238E27FC236}">
-                <a16:creationId xmlns:a16="http://schemas.microsoft.com/office/drawing/2014/main" id="{C89A55E5-1BC0-5597-3D88-0FBA917211B8}"/>
+                <a16:creationId xmlns:a16="http://schemas.microsoft.com/office/drawing/2014/main" id="{B48D5E4E-7ED1-9037-E819-EB17FC1894CA}"/>
               </a:ext>
             </a:extLst>
           </p:cNvPr>
@@ -11419,7 +11419,7 @@
           <p:cNvPr id="39" name="s12 lesson2">
             <a:extLst>
               <a:ext uri="{FF2B5EF4-FFF2-40B4-BE49-F238E27FC236}">
-                <a16:creationId xmlns:a16="http://schemas.microsoft.com/office/drawing/2014/main" id="{0F6501B5-F1C2-4D6B-29E9-D3FEAE6936CC}"/>
+                <a16:creationId xmlns:a16="http://schemas.microsoft.com/office/drawing/2014/main" id="{1187A734-3C74-FB8E-AE0A-EC5823EEB143}"/>
               </a:ext>
             </a:extLst>
           </p:cNvPr>
@@ -11611,7 +11611,7 @@
           <p:cNvPr id="40" name="s12 limits">
             <a:extLst>
               <a:ext uri="{FF2B5EF4-FFF2-40B4-BE49-F238E27FC236}">
-                <a16:creationId xmlns:a16="http://schemas.microsoft.com/office/drawing/2014/main" id="{507EB567-BCBF-B391-0925-1774D3F801BE}"/>
+                <a16:creationId xmlns:a16="http://schemas.microsoft.com/office/drawing/2014/main" id="{21CA45B3-7FC8-5099-57F3-DE303ADAF294}"/>
               </a:ext>
             </a:extLst>
           </p:cNvPr>
@@ -12770,7 +12770,7 @@
           <p:cNvPr id="32" name="s13 qrs">
             <a:extLst>
               <a:ext uri="{FF2B5EF4-FFF2-40B4-BE49-F238E27FC236}">
-                <a16:creationId xmlns:a16="http://schemas.microsoft.com/office/drawing/2014/main" id="{68FE65E2-996D-4D9A-FF97-D1E0908640E4}"/>
+                <a16:creationId xmlns:a16="http://schemas.microsoft.com/office/drawing/2014/main" id="{5803A663-0C11-B3E3-74F0-B26EE25222CA}"/>
               </a:ext>
             </a:extLst>
           </p:cNvPr>
@@ -13018,7 +13018,7 @@
           <p:cNvPr id="33" name="s13 nav">
             <a:extLst>
               <a:ext uri="{FF2B5EF4-FFF2-40B4-BE49-F238E27FC236}">
-                <a16:creationId xmlns:a16="http://schemas.microsoft.com/office/drawing/2014/main" id="{EADEA5B2-B906-9D2A-E1EC-D04064D395D9}"/>
+                <a16:creationId xmlns:a16="http://schemas.microsoft.com/office/drawing/2014/main" id="{65D3D77B-AC43-5AE3-EA42-5E6B22F88569}"/>
               </a:ext>
             </a:extLst>
           </p:cNvPr>
@@ -14368,7 +14368,7 @@
           <p:cNvPr id="26" name="s14 t1">
             <a:extLst>
               <a:ext uri="{FF2B5EF4-FFF2-40B4-BE49-F238E27FC236}">
-                <a16:creationId xmlns:a16="http://schemas.microsoft.com/office/drawing/2014/main" id="{0C950C32-EDD2-31B5-86D0-DEE257C81ADB}"/>
+                <a16:creationId xmlns:a16="http://schemas.microsoft.com/office/drawing/2014/main" id="{DB173E56-5350-BE86-BAF4-D52D1AA9015F}"/>
               </a:ext>
             </a:extLst>
           </p:cNvPr>
@@ -14535,7 +14535,7 @@
           <p:cNvPr id="27" name="s14 t2">
             <a:extLst>
               <a:ext uri="{FF2B5EF4-FFF2-40B4-BE49-F238E27FC236}">
-                <a16:creationId xmlns:a16="http://schemas.microsoft.com/office/drawing/2014/main" id="{525A9DFC-D5DE-82F6-6422-6B2BCEDE74F8}"/>
+                <a16:creationId xmlns:a16="http://schemas.microsoft.com/office/drawing/2014/main" id="{BB3668AC-B66C-411D-8907-B45F99A887FB}"/>
               </a:ext>
             </a:extLst>
           </p:cNvPr>
@@ -14702,7 +14702,7 @@
           <p:cNvPr id="28" name="s14 t3">
             <a:extLst>
               <a:ext uri="{FF2B5EF4-FFF2-40B4-BE49-F238E27FC236}">
-                <a16:creationId xmlns:a16="http://schemas.microsoft.com/office/drawing/2014/main" id="{A397E155-D513-A328-5CFE-32F22FA7997A}"/>
+                <a16:creationId xmlns:a16="http://schemas.microsoft.com/office/drawing/2014/main" id="{364D28F0-3404-9AD7-57C0-F9130E9F96F4}"/>
               </a:ext>
             </a:extLst>
           </p:cNvPr>
@@ -19561,7 +19561,7 @@
           <p:cNvPr id="28" name="s16 t1">
             <a:extLst>
               <a:ext uri="{FF2B5EF4-FFF2-40B4-BE49-F238E27FC236}">
-                <a16:creationId xmlns:a16="http://schemas.microsoft.com/office/drawing/2014/main" id="{1DA070F4-BC0E-08FA-F5C4-3FE0F4B8E52C}"/>
+                <a16:creationId xmlns:a16="http://schemas.microsoft.com/office/drawing/2014/main" id="{520341FE-4D23-96FF-2D02-4A7C3751AA7B}"/>
               </a:ext>
             </a:extLst>
           </p:cNvPr>
@@ -19728,7 +19728,7 @@
           <p:cNvPr id="29" name="s16 t2">
             <a:extLst>
               <a:ext uri="{FF2B5EF4-FFF2-40B4-BE49-F238E27FC236}">
-                <a16:creationId xmlns:a16="http://schemas.microsoft.com/office/drawing/2014/main" id="{E71C8738-1E3B-6CA9-0988-EB782A9A3DE1}"/>
+                <a16:creationId xmlns:a16="http://schemas.microsoft.com/office/drawing/2014/main" id="{96AC3824-2553-89C1-94F6-611E5AC424FE}"/>
               </a:ext>
             </a:extLst>
           </p:cNvPr>
@@ -19895,7 +19895,7 @@
           <p:cNvPr id="30" name="s16 t3">
             <a:extLst>
               <a:ext uri="{FF2B5EF4-FFF2-40B4-BE49-F238E27FC236}">
-                <a16:creationId xmlns:a16="http://schemas.microsoft.com/office/drawing/2014/main" id="{A9F6525B-036C-F032-2C5E-19950F590C13}"/>
+                <a16:creationId xmlns:a16="http://schemas.microsoft.com/office/drawing/2014/main" id="{3E4236F2-689A-FAB8-5A15-CFF468A4CE16}"/>
               </a:ext>
             </a:extLst>
           </p:cNvPr>
@@ -20338,7 +20338,7 @@
           <p:cNvPr id="21" name="s17 t1">
             <a:extLst>
               <a:ext uri="{FF2B5EF4-FFF2-40B4-BE49-F238E27FC236}">
-                <a16:creationId xmlns:a16="http://schemas.microsoft.com/office/drawing/2014/main" id="{BA09BB27-D87F-09F4-9244-105D87F2B99D}"/>
+                <a16:creationId xmlns:a16="http://schemas.microsoft.com/office/drawing/2014/main" id="{0DCBF6FD-18FB-DDC6-4945-B72BBCD7B679}"/>
               </a:ext>
             </a:extLst>
           </p:cNvPr>
@@ -20505,7 +20505,7 @@
           <p:cNvPr id="22" name="s17 t2">
             <a:extLst>
               <a:ext uri="{FF2B5EF4-FFF2-40B4-BE49-F238E27FC236}">
-                <a16:creationId xmlns:a16="http://schemas.microsoft.com/office/drawing/2014/main" id="{825CD54E-6BF0-27E7-69C8-F85625C3F986}"/>
+                <a16:creationId xmlns:a16="http://schemas.microsoft.com/office/drawing/2014/main" id="{CC86C1C5-EBE2-8CAF-A860-A348BC63AE77}"/>
               </a:ext>
             </a:extLst>
           </p:cNvPr>
@@ -20672,7 +20672,7 @@
           <p:cNvPr id="23" name="s17 t3">
             <a:extLst>
               <a:ext uri="{FF2B5EF4-FFF2-40B4-BE49-F238E27FC236}">
-                <a16:creationId xmlns:a16="http://schemas.microsoft.com/office/drawing/2014/main" id="{42DF5CEE-5FE1-5636-FBBA-4D83AB769E68}"/>
+                <a16:creationId xmlns:a16="http://schemas.microsoft.com/office/drawing/2014/main" id="{023123F0-A568-2A23-5436-B3105E7EDE70}"/>
               </a:ext>
             </a:extLst>
           </p:cNvPr>
@@ -21076,7 +21076,7 @@
           <p:cNvPr id="20" name="s18 t1">
             <a:extLst>
               <a:ext uri="{FF2B5EF4-FFF2-40B4-BE49-F238E27FC236}">
-                <a16:creationId xmlns:a16="http://schemas.microsoft.com/office/drawing/2014/main" id="{0D5900F9-1D03-3A1D-A5EB-48E1D28F9F84}"/>
+                <a16:creationId xmlns:a16="http://schemas.microsoft.com/office/drawing/2014/main" id="{B4AC25EF-A5E5-5BA5-1189-ABA5975FB5A2}"/>
               </a:ext>
             </a:extLst>
           </p:cNvPr>
@@ -21243,7 +21243,7 @@
           <p:cNvPr id="21" name="s18 t2">
             <a:extLst>
               <a:ext uri="{FF2B5EF4-FFF2-40B4-BE49-F238E27FC236}">
-                <a16:creationId xmlns:a16="http://schemas.microsoft.com/office/drawing/2014/main" id="{2747A604-864D-BA94-18E9-20C89350F550}"/>
+                <a16:creationId xmlns:a16="http://schemas.microsoft.com/office/drawing/2014/main" id="{CF9CF920-4EC7-D0E1-1674-4D4414A30B1E}"/>
               </a:ext>
             </a:extLst>
           </p:cNvPr>
@@ -21410,7 +21410,7 @@
           <p:cNvPr id="22" name="s18 t3">
             <a:extLst>
               <a:ext uri="{FF2B5EF4-FFF2-40B4-BE49-F238E27FC236}">
-                <a16:creationId xmlns:a16="http://schemas.microsoft.com/office/drawing/2014/main" id="{096F6899-8AB9-A365-22CE-57355C779A26}"/>
+                <a16:creationId xmlns:a16="http://schemas.microsoft.com/office/drawing/2014/main" id="{03CA3A06-E6C0-4CCA-A786-1E4BC214DFA2}"/>
               </a:ext>
             </a:extLst>
           </p:cNvPr>
@@ -23501,7 +23501,7 @@
           <p:cNvPr id="6" name="s19 t1">
             <a:extLst>
               <a:ext uri="{FF2B5EF4-FFF2-40B4-BE49-F238E27FC236}">
-                <a16:creationId xmlns:a16="http://schemas.microsoft.com/office/drawing/2014/main" id="{EC016F77-88AE-D9E2-2138-1DEA2A3F2CD8}"/>
+                <a16:creationId xmlns:a16="http://schemas.microsoft.com/office/drawing/2014/main" id="{D7113B07-88D5-863B-E7E3-50A3883274AE}"/>
               </a:ext>
             </a:extLst>
           </p:cNvPr>
@@ -23668,7 +23668,7 @@
           <p:cNvPr id="19" name="s19 t2">
             <a:extLst>
               <a:ext uri="{FF2B5EF4-FFF2-40B4-BE49-F238E27FC236}">
-                <a16:creationId xmlns:a16="http://schemas.microsoft.com/office/drawing/2014/main" id="{C6EC1C4B-F71F-CFE4-E98B-975128A8C3E3}"/>
+                <a16:creationId xmlns:a16="http://schemas.microsoft.com/office/drawing/2014/main" id="{775759D3-0EB7-7901-78A9-9292877F2D26}"/>
               </a:ext>
             </a:extLst>
           </p:cNvPr>
@@ -23835,7 +23835,7 @@
           <p:cNvPr id="21" name="s19 t3">
             <a:extLst>
               <a:ext uri="{FF2B5EF4-FFF2-40B4-BE49-F238E27FC236}">
-                <a16:creationId xmlns:a16="http://schemas.microsoft.com/office/drawing/2014/main" id="{45EA70C4-809F-3CD4-26D6-0CAEF35F8732}"/>
+                <a16:creationId xmlns:a16="http://schemas.microsoft.com/office/drawing/2014/main" id="{DD37BF78-AE83-F30A-0783-7BE0FF864467}"/>
               </a:ext>
             </a:extLst>
           </p:cNvPr>
@@ -24171,7 +24171,7 @@
           <p:cNvPr id="43" name="s2 places">
             <a:extLst>
               <a:ext uri="{FF2B5EF4-FFF2-40B4-BE49-F238E27FC236}">
-                <a16:creationId xmlns:a16="http://schemas.microsoft.com/office/drawing/2014/main" id="{8E500D0B-1EE2-F042-66CD-382CB3A84916}"/>
+                <a16:creationId xmlns:a16="http://schemas.microsoft.com/office/drawing/2014/main" id="{7EFFCE79-9863-4563-8C75-653E124F6034}"/>
               </a:ext>
             </a:extLst>
           </p:cNvPr>
@@ -24436,7 +24436,7 @@
           <p:cNvPr id="38" name="s2 row0">
             <a:extLst>
               <a:ext uri="{FF2B5EF4-FFF2-40B4-BE49-F238E27FC236}">
-                <a16:creationId xmlns:a16="http://schemas.microsoft.com/office/drawing/2014/main" id="{ED48F794-9E7C-A053-3C49-4ECF9387E8E3}"/>
+                <a16:creationId xmlns:a16="http://schemas.microsoft.com/office/drawing/2014/main" id="{4454B862-3EAA-4121-1A1E-5C6D6AACB76B}"/>
               </a:ext>
             </a:extLst>
           </p:cNvPr>
@@ -24595,7 +24595,7 @@
           <p:cNvPr id="39" name="s2 row1">
             <a:extLst>
               <a:ext uri="{FF2B5EF4-FFF2-40B4-BE49-F238E27FC236}">
-                <a16:creationId xmlns:a16="http://schemas.microsoft.com/office/drawing/2014/main" id="{38F3E3D0-0DAF-1D87-017D-C8225AC6C70D}"/>
+                <a16:creationId xmlns:a16="http://schemas.microsoft.com/office/drawing/2014/main" id="{301CE457-0E60-896F-59A2-2DBD97ACF164}"/>
               </a:ext>
             </a:extLst>
           </p:cNvPr>
@@ -24705,7 +24705,7 @@
           <p:cNvPr id="40" name="s2 row2">
             <a:extLst>
               <a:ext uri="{FF2B5EF4-FFF2-40B4-BE49-F238E27FC236}">
-                <a16:creationId xmlns:a16="http://schemas.microsoft.com/office/drawing/2014/main" id="{68442724-1D39-26A1-EDDB-CBBEBD81EBB0}"/>
+                <a16:creationId xmlns:a16="http://schemas.microsoft.com/office/drawing/2014/main" id="{13432DC2-FAEA-FDD1-AC07-593DDBDA32A2}"/>
               </a:ext>
             </a:extLst>
           </p:cNvPr>
@@ -24913,7 +24913,7 @@
           <p:cNvPr id="41" name="s2 row3">
             <a:extLst>
               <a:ext uri="{FF2B5EF4-FFF2-40B4-BE49-F238E27FC236}">
-                <a16:creationId xmlns:a16="http://schemas.microsoft.com/office/drawing/2014/main" id="{12CD9FF5-2306-7FB7-0D31-907CBD3F27C0}"/>
+                <a16:creationId xmlns:a16="http://schemas.microsoft.com/office/drawing/2014/main" id="{819C723D-71F9-1575-51F0-43F687ED586E}"/>
               </a:ext>
             </a:extLst>
           </p:cNvPr>
@@ -25072,7 +25072,7 @@
           <p:cNvPr id="42" name="s2 row4">
             <a:extLst>
               <a:ext uri="{FF2B5EF4-FFF2-40B4-BE49-F238E27FC236}">
-                <a16:creationId xmlns:a16="http://schemas.microsoft.com/office/drawing/2014/main" id="{5AB7BF6A-03AD-22EB-8437-213DB4848F54}"/>
+                <a16:creationId xmlns:a16="http://schemas.microsoft.com/office/drawing/2014/main" id="{AC61B452-3051-F16F-D1FF-E8DD2DDF4EA7}"/>
               </a:ext>
             </a:extLst>
           </p:cNvPr>
@@ -28229,7 +28229,7 @@
           <p:cNvPr id="69" name="s3 numbers">
             <a:extLst>
               <a:ext uri="{FF2B5EF4-FFF2-40B4-BE49-F238E27FC236}">
-                <a16:creationId xmlns:a16="http://schemas.microsoft.com/office/drawing/2014/main" id="{AD5A1554-B407-E81B-E458-205000DAB648}"/>
+                <a16:creationId xmlns:a16="http://schemas.microsoft.com/office/drawing/2014/main" id="{EDF59B4E-35A3-EC87-2E42-5C73B85F87DD}"/>
               </a:ext>
             </a:extLst>
           </p:cNvPr>
@@ -28484,7 +28484,7 @@
           <p:cNvPr id="59" name="s3 cite">
             <a:extLst>
               <a:ext uri="{FF2B5EF4-FFF2-40B4-BE49-F238E27FC236}">
-                <a16:creationId xmlns:a16="http://schemas.microsoft.com/office/drawing/2014/main" id="{19998F30-6EDF-7D12-8DD0-B8C367BF954F}"/>
+                <a16:creationId xmlns:a16="http://schemas.microsoft.com/office/drawing/2014/main" id="{117FD374-8AE8-D38C-F1A6-82B74E00617C}"/>
               </a:ext>
             </a:extLst>
           </p:cNvPr>
@@ -28617,7 +28617,7 @@
           <p:cNvPr id="70" name="s3 chartcard">
             <a:extLst>
               <a:ext uri="{FF2B5EF4-FFF2-40B4-BE49-F238E27FC236}">
-                <a16:creationId xmlns:a16="http://schemas.microsoft.com/office/drawing/2014/main" id="{3D3DF4D7-B097-876A-6D80-67485325D3E2}"/>
+                <a16:creationId xmlns:a16="http://schemas.microsoft.com/office/drawing/2014/main" id="{EB73BC80-909F-BC07-B7BD-B1FB9E175ED7}"/>
               </a:ext>
             </a:extLst>
           </p:cNvPr>
@@ -28711,7 +28711,7 @@
           <p:cNvPr id="66" name="s3 cats">
             <a:extLst>
               <a:ext uri="{FF2B5EF4-FFF2-40B4-BE49-F238E27FC236}">
-                <a16:creationId xmlns:a16="http://schemas.microsoft.com/office/drawing/2014/main" id="{CFA2AB31-5003-6C85-EBED-EFD2FC917A5F}"/>
+                <a16:creationId xmlns:a16="http://schemas.microsoft.com/office/drawing/2014/main" id="{01F62DDE-5A0E-6557-2AF4-04BA543BADAB}"/>
               </a:ext>
             </a:extLst>
           </p:cNvPr>
@@ -29091,7 +29091,7 @@
           <p:cNvPr id="60" name="s3 bar0">
             <a:extLst>
               <a:ext uri="{FF2B5EF4-FFF2-40B4-BE49-F238E27FC236}">
-                <a16:creationId xmlns:a16="http://schemas.microsoft.com/office/drawing/2014/main" id="{9716AA28-6863-277A-1814-8526132B8DBB}"/>
+                <a16:creationId xmlns:a16="http://schemas.microsoft.com/office/drawing/2014/main" id="{38D722C3-2B3B-1EC1-B192-615397A13BD5}"/>
               </a:ext>
             </a:extLst>
           </p:cNvPr>
@@ -29180,7 +29180,7 @@
           <p:cNvPr id="61" name="s3 bar1">
             <a:extLst>
               <a:ext uri="{FF2B5EF4-FFF2-40B4-BE49-F238E27FC236}">
-                <a16:creationId xmlns:a16="http://schemas.microsoft.com/office/drawing/2014/main" id="{E4FAE36C-B55A-D816-E0B4-E66EFD96FA90}"/>
+                <a16:creationId xmlns:a16="http://schemas.microsoft.com/office/drawing/2014/main" id="{D7279FF5-AB2A-A08B-50A1-A0D48C177273}"/>
               </a:ext>
             </a:extLst>
           </p:cNvPr>
@@ -29269,7 +29269,7 @@
           <p:cNvPr id="62" name="s3 bar2">
             <a:extLst>
               <a:ext uri="{FF2B5EF4-FFF2-40B4-BE49-F238E27FC236}">
-                <a16:creationId xmlns:a16="http://schemas.microsoft.com/office/drawing/2014/main" id="{7DCB3CFD-4D84-185F-AB83-9FC5C5519314}"/>
+                <a16:creationId xmlns:a16="http://schemas.microsoft.com/office/drawing/2014/main" id="{8D6F76EC-A236-DBB0-808F-FD7C87B50D1C}"/>
               </a:ext>
             </a:extLst>
           </p:cNvPr>
@@ -29358,7 +29358,7 @@
           <p:cNvPr id="63" name="s3 bar3">
             <a:extLst>
               <a:ext uri="{FF2B5EF4-FFF2-40B4-BE49-F238E27FC236}">
-                <a16:creationId xmlns:a16="http://schemas.microsoft.com/office/drawing/2014/main" id="{87BA1DF6-E602-B148-A4D2-77AF5A816630}"/>
+                <a16:creationId xmlns:a16="http://schemas.microsoft.com/office/drawing/2014/main" id="{42B4D11C-3E46-513F-1AC6-53BCC40FBA1C}"/>
               </a:ext>
             </a:extLst>
           </p:cNvPr>
@@ -29447,7 +29447,7 @@
           <p:cNvPr id="64" name="s3 bar4">
             <a:extLst>
               <a:ext uri="{FF2B5EF4-FFF2-40B4-BE49-F238E27FC236}">
-                <a16:creationId xmlns:a16="http://schemas.microsoft.com/office/drawing/2014/main" id="{A633BEB3-404B-0F75-3947-92964AAF9B5F}"/>
+                <a16:creationId xmlns:a16="http://schemas.microsoft.com/office/drawing/2014/main" id="{A66B6CE2-C209-6F52-4E6D-D89E06501556}"/>
               </a:ext>
             </a:extLst>
           </p:cNvPr>
@@ -29536,7 +29536,7 @@
           <p:cNvPr id="65" name="s3 bar5">
             <a:extLst>
               <a:ext uri="{FF2B5EF4-FFF2-40B4-BE49-F238E27FC236}">
-                <a16:creationId xmlns:a16="http://schemas.microsoft.com/office/drawing/2014/main" id="{A785EFC0-3CFB-F342-1CBB-24749C72AF81}"/>
+                <a16:creationId xmlns:a16="http://schemas.microsoft.com/office/drawing/2014/main" id="{F5624389-6CBE-98BA-E2DF-9CF123484410}"/>
               </a:ext>
             </a:extLst>
           </p:cNvPr>
@@ -29625,7 +29625,7 @@
           <p:cNvPr id="67" name="s3 tileA">
             <a:extLst>
               <a:ext uri="{FF2B5EF4-FFF2-40B4-BE49-F238E27FC236}">
-                <a16:creationId xmlns:a16="http://schemas.microsoft.com/office/drawing/2014/main" id="{17689B15-3483-1951-8594-EA76D7C6E5FD}"/>
+                <a16:creationId xmlns:a16="http://schemas.microsoft.com/office/drawing/2014/main" id="{5E7F6379-DDFF-C4B8-86EE-EDB1407BBE84}"/>
               </a:ext>
             </a:extLst>
           </p:cNvPr>
@@ -29792,7 +29792,7 @@
           <p:cNvPr id="68" name="s3 tileB">
             <a:extLst>
               <a:ext uri="{FF2B5EF4-FFF2-40B4-BE49-F238E27FC236}">
-                <a16:creationId xmlns:a16="http://schemas.microsoft.com/office/drawing/2014/main" id="{ECC6409D-7EF3-1D8C-27AC-54F369CFEB2C}"/>
+                <a16:creationId xmlns:a16="http://schemas.microsoft.com/office/drawing/2014/main" id="{E800F914-AE85-4A71-0E81-E40A35AB0426}"/>
               </a:ext>
             </a:extLst>
           </p:cNvPr>
@@ -31223,7 +31223,7 @@
           <p:cNvPr id="45" name="s4 stages">
             <a:extLst>
               <a:ext uri="{FF2B5EF4-FFF2-40B4-BE49-F238E27FC236}">
-                <a16:creationId xmlns:a16="http://schemas.microsoft.com/office/drawing/2014/main" id="{C71791BD-228E-43F2-B0E7-94058F3ABB43}"/>
+                <a16:creationId xmlns:a16="http://schemas.microsoft.com/office/drawing/2014/main" id="{D51772E5-1B59-8973-6EE9-5EBA5089F0A7}"/>
               </a:ext>
             </a:extLst>
           </p:cNvPr>
@@ -31547,7 +31547,7 @@
           <p:cNvPr id="42" name="s4 card0">
             <a:extLst>
               <a:ext uri="{FF2B5EF4-FFF2-40B4-BE49-F238E27FC236}">
-                <a16:creationId xmlns:a16="http://schemas.microsoft.com/office/drawing/2014/main" id="{D9924EBC-0AE3-3938-F4D7-D7B521DE12FF}"/>
+                <a16:creationId xmlns:a16="http://schemas.microsoft.com/office/drawing/2014/main" id="{E7059E37-5FFB-8F99-108A-00FAF7D92C6F}"/>
               </a:ext>
             </a:extLst>
           </p:cNvPr>
@@ -31753,7 +31753,7 @@
           <p:cNvPr id="43" name="s4 card1">
             <a:extLst>
               <a:ext uri="{FF2B5EF4-FFF2-40B4-BE49-F238E27FC236}">
-                <a16:creationId xmlns:a16="http://schemas.microsoft.com/office/drawing/2014/main" id="{DC5747BF-CE5B-BCDA-9984-A9C03A3C2ABA}"/>
+                <a16:creationId xmlns:a16="http://schemas.microsoft.com/office/drawing/2014/main" id="{7C255228-2ACF-DF0D-A988-65FF468280B4}"/>
               </a:ext>
             </a:extLst>
           </p:cNvPr>
@@ -31959,7 +31959,7 @@
           <p:cNvPr id="44" name="s4 card2">
             <a:extLst>
               <a:ext uri="{FF2B5EF4-FFF2-40B4-BE49-F238E27FC236}">
-                <a16:creationId xmlns:a16="http://schemas.microsoft.com/office/drawing/2014/main" id="{DD040DD6-86AF-3299-665D-9AF49A227735}"/>
+                <a16:creationId xmlns:a16="http://schemas.microsoft.com/office/drawing/2014/main" id="{88BF2333-86DE-973B-989D-F26668DB8CD4}"/>
               </a:ext>
             </a:extLst>
           </p:cNvPr>
@@ -32165,7 +32165,7 @@
           <p:cNvPr id="46" name="s4 review">
             <a:extLst>
               <a:ext uri="{FF2B5EF4-FFF2-40B4-BE49-F238E27FC236}">
-                <a16:creationId xmlns:a16="http://schemas.microsoft.com/office/drawing/2014/main" id="{57F1FEF0-1203-F013-343D-0BBBA65E6B75}"/>
+                <a16:creationId xmlns:a16="http://schemas.microsoft.com/office/drawing/2014/main" id="{61B69B2B-C69B-D3B5-0F8E-55D363FB6C74}"/>
               </a:ext>
             </a:extLst>
           </p:cNvPr>
@@ -33358,7 +33358,7 @@
           <p:cNvPr id="38" name="s5 panel">
             <a:extLst>
               <a:ext uri="{FF2B5EF4-FFF2-40B4-BE49-F238E27FC236}">
-                <a16:creationId xmlns:a16="http://schemas.microsoft.com/office/drawing/2014/main" id="{D6184C77-8528-4DF0-3D99-9DFA2D5C3F8D}"/>
+                <a16:creationId xmlns:a16="http://schemas.microsoft.com/office/drawing/2014/main" id="{9B23EBCC-8F3D-5ACF-9152-FDB6643F5EEA}"/>
               </a:ext>
             </a:extLst>
           </p:cNvPr>
@@ -33516,7 +33516,7 @@
           <p:cNvPr id="35" name="s5 row0">
             <a:extLst>
               <a:ext uri="{FF2B5EF4-FFF2-40B4-BE49-F238E27FC236}">
-                <a16:creationId xmlns:a16="http://schemas.microsoft.com/office/drawing/2014/main" id="{BDFE4897-C692-D8A3-5395-60CE3EC1DADA}"/>
+                <a16:creationId xmlns:a16="http://schemas.microsoft.com/office/drawing/2014/main" id="{3371FACF-5C89-BEA7-C211-E5ACDE15A6BF}"/>
               </a:ext>
             </a:extLst>
           </p:cNvPr>
@@ -33664,7 +33664,7 @@
           <p:cNvPr id="36" name="s5 row1">
             <a:extLst>
               <a:ext uri="{FF2B5EF4-FFF2-40B4-BE49-F238E27FC236}">
-                <a16:creationId xmlns:a16="http://schemas.microsoft.com/office/drawing/2014/main" id="{12BF45C9-1906-FECF-54C9-8AD5C4A582ED}"/>
+                <a16:creationId xmlns:a16="http://schemas.microsoft.com/office/drawing/2014/main" id="{24C8DDEF-277B-0FC8-C97B-C87088E34238}"/>
               </a:ext>
             </a:extLst>
           </p:cNvPr>
@@ -33812,7 +33812,7 @@
           <p:cNvPr id="37" name="s5 row2">
             <a:extLst>
               <a:ext uri="{FF2B5EF4-FFF2-40B4-BE49-F238E27FC236}">
-                <a16:creationId xmlns:a16="http://schemas.microsoft.com/office/drawing/2014/main" id="{DD9AC770-B3C1-BE41-CCDA-67ED5F8EB034}"/>
+                <a16:creationId xmlns:a16="http://schemas.microsoft.com/office/drawing/2014/main" id="{05E4B12E-E9C6-D0E3-4483-2F1858771A2A}"/>
               </a:ext>
             </a:extLst>
           </p:cNvPr>
@@ -35060,7 +35060,7 @@
           <p:cNvPr id="56" name="s6 input">
             <a:extLst>
               <a:ext uri="{FF2B5EF4-FFF2-40B4-BE49-F238E27FC236}">
-                <a16:creationId xmlns:a16="http://schemas.microsoft.com/office/drawing/2014/main" id="{E3B02D40-4FDC-44E9-9D09-9F131C2EE714}"/>
+                <a16:creationId xmlns:a16="http://schemas.microsoft.com/office/drawing/2014/main" id="{66CC15BF-571A-8E80-63F9-3F852064D1A6}"/>
               </a:ext>
             </a:extLst>
           </p:cNvPr>
@@ -35384,7 +35384,7 @@
           <p:cNvPr id="53" name="s6 comp0">
             <a:extLst>
               <a:ext uri="{FF2B5EF4-FFF2-40B4-BE49-F238E27FC236}">
-                <a16:creationId xmlns:a16="http://schemas.microsoft.com/office/drawing/2014/main" id="{DC70C40C-63AA-A606-C08E-D6B04B1031FC}"/>
+                <a16:creationId xmlns:a16="http://schemas.microsoft.com/office/drawing/2014/main" id="{959F1862-46A0-E651-AD9B-DCA93618D25B}"/>
               </a:ext>
             </a:extLst>
           </p:cNvPr>
@@ -35641,7 +35641,7 @@
           <p:cNvPr id="54" name="s6 comp1">
             <a:extLst>
               <a:ext uri="{FF2B5EF4-FFF2-40B4-BE49-F238E27FC236}">
-                <a16:creationId xmlns:a16="http://schemas.microsoft.com/office/drawing/2014/main" id="{A95FF849-ADE3-D72E-F212-C998AA3909E6}"/>
+                <a16:creationId xmlns:a16="http://schemas.microsoft.com/office/drawing/2014/main" id="{99D83AFF-E1EE-A773-9D67-F53058B80899}"/>
               </a:ext>
             </a:extLst>
           </p:cNvPr>
@@ -35898,7 +35898,7 @@
           <p:cNvPr id="55" name="s6 comp2">
             <a:extLst>
               <a:ext uri="{FF2B5EF4-FFF2-40B4-BE49-F238E27FC236}">
-                <a16:creationId xmlns:a16="http://schemas.microsoft.com/office/drawing/2014/main" id="{705FEAF8-DEB6-E73E-40A8-B6AF22E789CE}"/>
+                <a16:creationId xmlns:a16="http://schemas.microsoft.com/office/drawing/2014/main" id="{637E50F0-4264-D75D-1D62-18AD65F47E3E}"/>
               </a:ext>
             </a:extLst>
           </p:cNvPr>
@@ -36155,7 +36155,7 @@
           <p:cNvPr id="57" name="s6 hood">
             <a:extLst>
               <a:ext uri="{FF2B5EF4-FFF2-40B4-BE49-F238E27FC236}">
-                <a16:creationId xmlns:a16="http://schemas.microsoft.com/office/drawing/2014/main" id="{080CAB72-F4E1-250A-33EA-EB32DC4F0899}"/>
+                <a16:creationId xmlns:a16="http://schemas.microsoft.com/office/drawing/2014/main" id="{A143D11E-7323-412E-8185-1C13C79969AC}"/>
               </a:ext>
             </a:extLst>
           </p:cNvPr>
@@ -37509,7 +37509,7 @@
           <p:cNvPr id="42" name="s7 card">
             <a:extLst>
               <a:ext uri="{FF2B5EF4-FFF2-40B4-BE49-F238E27FC236}">
-                <a16:creationId xmlns:a16="http://schemas.microsoft.com/office/drawing/2014/main" id="{CD41C8D1-4A6B-28FB-ED2D-60B004D590BA}"/>
+                <a16:creationId xmlns:a16="http://schemas.microsoft.com/office/drawing/2014/main" id="{B77DD2EA-5AF6-6B8A-0F86-3AA49CDE5243}"/>
               </a:ext>
             </a:extLst>
           </p:cNvPr>
@@ -37934,7 +37934,7 @@
           <p:cNvPr id="40" name="s7 tileA">
             <a:extLst>
               <a:ext uri="{FF2B5EF4-FFF2-40B4-BE49-F238E27FC236}">
-                <a16:creationId xmlns:a16="http://schemas.microsoft.com/office/drawing/2014/main" id="{55F2139C-7EFF-3C65-EFBF-5DC76F6F9E42}"/>
+                <a16:creationId xmlns:a16="http://schemas.microsoft.com/office/drawing/2014/main" id="{021926BD-B860-742C-C409-3142A1462636}"/>
               </a:ext>
             </a:extLst>
           </p:cNvPr>
@@ -38101,7 +38101,7 @@
           <p:cNvPr id="41" name="s7 tileB">
             <a:extLst>
               <a:ext uri="{FF2B5EF4-FFF2-40B4-BE49-F238E27FC236}">
-                <a16:creationId xmlns:a16="http://schemas.microsoft.com/office/drawing/2014/main" id="{23C7D505-3688-B8A4-4427-054F492DBEA7}"/>
+                <a16:creationId xmlns:a16="http://schemas.microsoft.com/office/drawing/2014/main" id="{D784AFEA-7184-BDB8-E656-375F20236317}"/>
               </a:ext>
             </a:extLst>
           </p:cNvPr>
@@ -39566,7 +39566,7 @@
           <p:cNvPr id="240" name="s8 waffleA">
             <a:extLst>
               <a:ext uri="{FF2B5EF4-FFF2-40B4-BE49-F238E27FC236}">
-                <a16:creationId xmlns:a16="http://schemas.microsoft.com/office/drawing/2014/main" id="{2B6FAF6D-CFAD-F75F-EEF7-410B81B2A16F}"/>
+                <a16:creationId xmlns:a16="http://schemas.microsoft.com/office/drawing/2014/main" id="{9261C4A1-4AD9-7357-AA26-C4E28A6CA3B3}"/>
               </a:ext>
             </a:extLst>
           </p:cNvPr>
@@ -42487,7 +42487,7 @@
           <p:cNvPr id="241" name="s8 numA">
             <a:extLst>
               <a:ext uri="{FF2B5EF4-FFF2-40B4-BE49-F238E27FC236}">
-                <a16:creationId xmlns:a16="http://schemas.microsoft.com/office/drawing/2014/main" id="{076304A6-71A5-84EF-5589-D9FEFB9A6955}"/>
+                <a16:creationId xmlns:a16="http://schemas.microsoft.com/office/drawing/2014/main" id="{AB0617B2-B90A-8469-42BF-69F48D742EF8}"/>
               </a:ext>
             </a:extLst>
           </p:cNvPr>
@@ -42603,7 +42603,7 @@
           <p:cNvPr id="247" name="s8 random">
             <a:extLst>
               <a:ext uri="{FF2B5EF4-FFF2-40B4-BE49-F238E27FC236}">
-                <a16:creationId xmlns:a16="http://schemas.microsoft.com/office/drawing/2014/main" id="{B3B7F3CA-678A-1E89-E04A-7452B961A62B}"/>
+                <a16:creationId xmlns:a16="http://schemas.microsoft.com/office/drawing/2014/main" id="{FB27C283-E61D-845C-B8C2-6C6AE1A4EE4A}"/>
               </a:ext>
             </a:extLst>
           </p:cNvPr>
@@ -42662,7 +42662,7 @@
             <p:cNvPr id="243" name="s8 numB">
               <a:extLst>
                 <a:ext uri="{FF2B5EF4-FFF2-40B4-BE49-F238E27FC236}">
-                  <a16:creationId xmlns:a16="http://schemas.microsoft.com/office/drawing/2014/main" id="{D0575E32-BF2C-A068-4D33-048122DA6E28}"/>
+                  <a16:creationId xmlns:a16="http://schemas.microsoft.com/office/drawing/2014/main" id="{2F840362-F379-1719-3258-A5D06A14C778}"/>
                 </a:ext>
               </a:extLst>
             </p:cNvPr>
@@ -42779,7 +42779,7 @@
           <p:cNvPr id="242" name="s8 waffleB">
             <a:extLst>
               <a:ext uri="{FF2B5EF4-FFF2-40B4-BE49-F238E27FC236}">
-                <a16:creationId xmlns:a16="http://schemas.microsoft.com/office/drawing/2014/main" id="{7802652F-EA64-BFCC-E2E9-8EA9FFA29941}"/>
+                <a16:creationId xmlns:a16="http://schemas.microsoft.com/office/drawing/2014/main" id="{EC04B536-C19B-3A73-DA3F-A8E0E6C69E77}"/>
               </a:ext>
             </a:extLst>
           </p:cNvPr>
@@ -45794,7 +45794,7 @@
           <p:cNvPr id="244" name="s8 tileA">
             <a:extLst>
               <a:ext uri="{FF2B5EF4-FFF2-40B4-BE49-F238E27FC236}">
-                <a16:creationId xmlns:a16="http://schemas.microsoft.com/office/drawing/2014/main" id="{40FE617C-9571-8777-5F13-4E918D6BA3E6}"/>
+                <a16:creationId xmlns:a16="http://schemas.microsoft.com/office/drawing/2014/main" id="{E14CEEBF-6936-8F08-1B0B-0E6F6019A70B}"/>
               </a:ext>
             </a:extLst>
           </p:cNvPr>
@@ -45961,7 +45961,7 @@
           <p:cNvPr id="245" name="s8 tileB">
             <a:extLst>
               <a:ext uri="{FF2B5EF4-FFF2-40B4-BE49-F238E27FC236}">
-                <a16:creationId xmlns:a16="http://schemas.microsoft.com/office/drawing/2014/main" id="{85D36714-1215-3DA5-CAE9-DEDD7DF0340D}"/>
+                <a16:creationId xmlns:a16="http://schemas.microsoft.com/office/drawing/2014/main" id="{4CDB2A61-8D0B-7BB9-61BC-187577C15092}"/>
               </a:ext>
             </a:extLst>
           </p:cNvPr>
@@ -46128,7 +46128,7 @@
           <p:cNvPr id="246" name="s8 tileC">
             <a:extLst>
               <a:ext uri="{FF2B5EF4-FFF2-40B4-BE49-F238E27FC236}">
-                <a16:creationId xmlns:a16="http://schemas.microsoft.com/office/drawing/2014/main" id="{B3AC3774-DD6B-CB1F-BD3D-484248611FF8}"/>
+                <a16:creationId xmlns:a16="http://schemas.microsoft.com/office/drawing/2014/main" id="{E36FDF21-75D8-E3E9-4F07-517F5CC73E17}"/>
               </a:ext>
             </a:extLst>
           </p:cNvPr>
@@ -47607,7 +47607,7 @@
           <p:cNvPr id="37" name="s9 browser">
             <a:extLst>
               <a:ext uri="{FF2B5EF4-FFF2-40B4-BE49-F238E27FC236}">
-                <a16:creationId xmlns:a16="http://schemas.microsoft.com/office/drawing/2014/main" id="{20C1770E-9CF4-73B8-2C11-D9D676DA4F51}"/>
+                <a16:creationId xmlns:a16="http://schemas.microsoft.com/office/drawing/2014/main" id="{402C3DE4-84CD-232D-DF2B-47AE16FDE9C9}"/>
               </a:ext>
             </a:extLst>
           </p:cNvPr>
@@ -47834,7 +47834,7 @@
           <p:cNvPr id="38" name="s9 live group">
             <a:extLst>
               <a:ext uri="{FF2B5EF4-FFF2-40B4-BE49-F238E27FC236}">
-                <a16:creationId xmlns:a16="http://schemas.microsoft.com/office/drawing/2014/main" id="{5F582DD2-A306-CF1C-7625-5997BD91E6B9}"/>
+                <a16:creationId xmlns:a16="http://schemas.microsoft.com/office/drawing/2014/main" id="{B571FEBB-F336-EBDE-6271-FC249CDBA719}"/>
               </a:ext>
             </a:extLst>
           </p:cNvPr>
@@ -47982,7 +47982,7 @@
           <p:cNvPr id="39" name="s9 result">
             <a:extLst>
               <a:ext uri="{FF2B5EF4-FFF2-40B4-BE49-F238E27FC236}">
-                <a16:creationId xmlns:a16="http://schemas.microsoft.com/office/drawing/2014/main" id="{AB6F6517-A351-736A-F0CF-CEE1D1C7C074}"/>
+                <a16:creationId xmlns:a16="http://schemas.microsoft.com/office/drawing/2014/main" id="{9C7EED4F-12E9-4A1F-DC20-AF1502081682}"/>
               </a:ext>
             </a:extLst>
           </p:cNvPr>

</xml_diff>

<commit_message>
Slides PDF includes the eight backup slides as an appendix
The PPTX keeps them hidden for the talk; the PDF copy now carries all 21
slides, including the app screens on the last backup slide.
</commit_message>
<xml_diff>
--- a/docs/Team10_Phase3_slides.pptx
+++ b/docs/Team10_Phase3_slides.pptx
@@ -199,7 +199,7 @@
             <c:bubble3D val="0"/>
             <c:extLst>
               <c:ext xmlns:c16="http://schemas.microsoft.com/office/drawing/2014/chart" uri="{C3380CC4-5D6E-409C-BE32-E72D297353CC}">
-                <c16:uniqueId val="{00000001-C3C3-4350-AAB1-2820CDB871BA}"/>
+                <c16:uniqueId val="{00000001-E0BE-4FA6-853C-4CF059ECF56A}"/>
               </c:ext>
             </c:extLst>
           </c:dPt>
@@ -209,7 +209,7 @@
             <c:bubble3D val="0"/>
             <c:extLst>
               <c:ext xmlns:c16="http://schemas.microsoft.com/office/drawing/2014/chart" uri="{C3380CC4-5D6E-409C-BE32-E72D297353CC}">
-                <c16:uniqueId val="{00000003-C3C3-4350-AAB1-2820CDB871BA}"/>
+                <c16:uniqueId val="{00000003-E0BE-4FA6-853C-4CF059ECF56A}"/>
               </c:ext>
             </c:extLst>
           </c:dPt>
@@ -219,7 +219,7 @@
             <c:bubble3D val="0"/>
             <c:extLst>
               <c:ext xmlns:c16="http://schemas.microsoft.com/office/drawing/2014/chart" uri="{C3380CC4-5D6E-409C-BE32-E72D297353CC}">
-                <c16:uniqueId val="{00000005-C3C3-4350-AAB1-2820CDB871BA}"/>
+                <c16:uniqueId val="{00000005-E0BE-4FA6-853C-4CF059ECF56A}"/>
               </c:ext>
             </c:extLst>
           </c:dPt>
@@ -229,7 +229,7 @@
             <c:bubble3D val="0"/>
             <c:extLst>
               <c:ext xmlns:c16="http://schemas.microsoft.com/office/drawing/2014/chart" uri="{C3380CC4-5D6E-409C-BE32-E72D297353CC}">
-                <c16:uniqueId val="{00000007-C3C3-4350-AAB1-2820CDB871BA}"/>
+                <c16:uniqueId val="{00000007-E0BE-4FA6-853C-4CF059ECF56A}"/>
               </c:ext>
             </c:extLst>
           </c:dPt>
@@ -239,7 +239,7 @@
             <c:bubble3D val="0"/>
             <c:extLst>
               <c:ext xmlns:c16="http://schemas.microsoft.com/office/drawing/2014/chart" uri="{C3380CC4-5D6E-409C-BE32-E72D297353CC}">
-                <c16:uniqueId val="{00000009-C3C3-4350-AAB1-2820CDB871BA}"/>
+                <c16:uniqueId val="{00000009-E0BE-4FA6-853C-4CF059ECF56A}"/>
               </c:ext>
             </c:extLst>
           </c:dPt>
@@ -249,7 +249,7 @@
             <c:bubble3D val="0"/>
             <c:extLst>
               <c:ext xmlns:c16="http://schemas.microsoft.com/office/drawing/2014/chart" uri="{C3380CC4-5D6E-409C-BE32-E72D297353CC}">
-                <c16:uniqueId val="{0000000B-C3C3-4350-AAB1-2820CDB871BA}"/>
+                <c16:uniqueId val="{0000000B-E0BE-4FA6-853C-4CF059ECF56A}"/>
               </c:ext>
             </c:extLst>
           </c:dPt>
@@ -259,7 +259,7 @@
             <c:bubble3D val="0"/>
             <c:extLst>
               <c:ext xmlns:c16="http://schemas.microsoft.com/office/drawing/2014/chart" uri="{C3380CC4-5D6E-409C-BE32-E72D297353CC}">
-                <c16:uniqueId val="{0000000D-C3C3-4350-AAB1-2820CDB871BA}"/>
+                <c16:uniqueId val="{0000000D-E0BE-4FA6-853C-4CF059ECF56A}"/>
               </c:ext>
             </c:extLst>
           </c:dPt>
@@ -269,7 +269,7 @@
             <c:bubble3D val="0"/>
             <c:extLst>
               <c:ext xmlns:c16="http://schemas.microsoft.com/office/drawing/2014/chart" uri="{C3380CC4-5D6E-409C-BE32-E72D297353CC}">
-                <c16:uniqueId val="{0000000F-C3C3-4350-AAB1-2820CDB871BA}"/>
+                <c16:uniqueId val="{0000000F-E0BE-4FA6-853C-4CF059ECF56A}"/>
               </c:ext>
             </c:extLst>
           </c:dPt>
@@ -279,7 +279,7 @@
             <c:bubble3D val="0"/>
             <c:extLst>
               <c:ext xmlns:c16="http://schemas.microsoft.com/office/drawing/2014/chart" uri="{C3380CC4-5D6E-409C-BE32-E72D297353CC}">
-                <c16:uniqueId val="{00000011-C3C3-4350-AAB1-2820CDB871BA}"/>
+                <c16:uniqueId val="{00000011-E0BE-4FA6-853C-4CF059ECF56A}"/>
               </c:ext>
             </c:extLst>
           </c:dPt>
@@ -289,7 +289,7 @@
             <c:bubble3D val="0"/>
             <c:extLst>
               <c:ext xmlns:c16="http://schemas.microsoft.com/office/drawing/2014/chart" uri="{C3380CC4-5D6E-409C-BE32-E72D297353CC}">
-                <c16:uniqueId val="{00000013-C3C3-4350-AAB1-2820CDB871BA}"/>
+                <c16:uniqueId val="{00000013-E0BE-4FA6-853C-4CF059ECF56A}"/>
               </c:ext>
             </c:extLst>
           </c:dPt>
@@ -305,7 +305,7 @@
             </c:spPr>
             <c:extLst>
               <c:ext xmlns:c16="http://schemas.microsoft.com/office/drawing/2014/chart" uri="{C3380CC4-5D6E-409C-BE32-E72D297353CC}">
-                <c16:uniqueId val="{00000015-C3C3-4350-AAB1-2820CDB871BA}"/>
+                <c16:uniqueId val="{00000015-E0BE-4FA6-853C-4CF059ECF56A}"/>
               </c:ext>
             </c:extLst>
           </c:dPt>
@@ -315,7 +315,7 @@
             <c:bubble3D val="0"/>
             <c:extLst>
               <c:ext xmlns:c16="http://schemas.microsoft.com/office/drawing/2014/chart" uri="{C3380CC4-5D6E-409C-BE32-E72D297353CC}">
-                <c16:uniqueId val="{00000017-C3C3-4350-AAB1-2820CDB871BA}"/>
+                <c16:uniqueId val="{00000017-E0BE-4FA6-853C-4CF059ECF56A}"/>
               </c:ext>
             </c:extLst>
           </c:dPt>
@@ -325,7 +325,7 @@
             <c:bubble3D val="0"/>
             <c:extLst>
               <c:ext xmlns:c16="http://schemas.microsoft.com/office/drawing/2014/chart" uri="{C3380CC4-5D6E-409C-BE32-E72D297353CC}">
-                <c16:uniqueId val="{00000019-C3C3-4350-AAB1-2820CDB871BA}"/>
+                <c16:uniqueId val="{00000019-E0BE-4FA6-853C-4CF059ECF56A}"/>
               </c:ext>
             </c:extLst>
           </c:dPt>
@@ -341,7 +341,7 @@
             </c:spPr>
             <c:extLst>
               <c:ext xmlns:c16="http://schemas.microsoft.com/office/drawing/2014/chart" uri="{C3380CC4-5D6E-409C-BE32-E72D297353CC}">
-                <c16:uniqueId val="{0000001B-C3C3-4350-AAB1-2820CDB871BA}"/>
+                <c16:uniqueId val="{0000001B-E0BE-4FA6-853C-4CF059ECF56A}"/>
               </c:ext>
             </c:extLst>
           </c:dPt>
@@ -357,7 +357,7 @@
             </c:spPr>
             <c:extLst>
               <c:ext xmlns:c16="http://schemas.microsoft.com/office/drawing/2014/chart" uri="{C3380CC4-5D6E-409C-BE32-E72D297353CC}">
-                <c16:uniqueId val="{0000001D-C3C3-4350-AAB1-2820CDB871BA}"/>
+                <c16:uniqueId val="{0000001D-E0BE-4FA6-853C-4CF059ECF56A}"/>
               </c:ext>
             </c:extLst>
           </c:dPt>
@@ -367,7 +367,7 @@
             <c:bubble3D val="0"/>
             <c:extLst>
               <c:ext xmlns:c16="http://schemas.microsoft.com/office/drawing/2014/chart" uri="{C3380CC4-5D6E-409C-BE32-E72D297353CC}">
-                <c16:uniqueId val="{0000001F-C3C3-4350-AAB1-2820CDB871BA}"/>
+                <c16:uniqueId val="{0000001F-E0BE-4FA6-853C-4CF059ECF56A}"/>
               </c:ext>
             </c:extLst>
           </c:dPt>
@@ -377,7 +377,7 @@
             <c:bubble3D val="0"/>
             <c:extLst>
               <c:ext xmlns:c16="http://schemas.microsoft.com/office/drawing/2014/chart" uri="{C3380CC4-5D6E-409C-BE32-E72D297353CC}">
-                <c16:uniqueId val="{00000021-C3C3-4350-AAB1-2820CDB871BA}"/>
+                <c16:uniqueId val="{00000021-E0BE-4FA6-853C-4CF059ECF56A}"/>
               </c:ext>
             </c:extLst>
           </c:dPt>
@@ -393,7 +393,7 @@
             </c:spPr>
             <c:extLst>
               <c:ext xmlns:c16="http://schemas.microsoft.com/office/drawing/2014/chart" uri="{C3380CC4-5D6E-409C-BE32-E72D297353CC}">
-                <c16:uniqueId val="{00000023-C3C3-4350-AAB1-2820CDB871BA}"/>
+                <c16:uniqueId val="{00000023-E0BE-4FA6-853C-4CF059ECF56A}"/>
               </c:ext>
             </c:extLst>
           </c:dPt>
@@ -403,7 +403,7 @@
             <c:bubble3D val="0"/>
             <c:extLst>
               <c:ext xmlns:c16="http://schemas.microsoft.com/office/drawing/2014/chart" uri="{C3380CC4-5D6E-409C-BE32-E72D297353CC}">
-                <c16:uniqueId val="{00000025-C3C3-4350-AAB1-2820CDB871BA}"/>
+                <c16:uniqueId val="{00000025-E0BE-4FA6-853C-4CF059ECF56A}"/>
               </c:ext>
             </c:extLst>
           </c:dPt>
@@ -413,7 +413,7 @@
             <c:bubble3D val="0"/>
             <c:extLst>
               <c:ext xmlns:c16="http://schemas.microsoft.com/office/drawing/2014/chart" uri="{C3380CC4-5D6E-409C-BE32-E72D297353CC}">
-                <c16:uniqueId val="{00000027-C3C3-4350-AAB1-2820CDB871BA}"/>
+                <c16:uniqueId val="{00000027-E0BE-4FA6-853C-4CF059ECF56A}"/>
               </c:ext>
             </c:extLst>
           </c:dPt>
@@ -556,7 +556,7 @@
           </c:val>
           <c:extLst>
             <c:ext xmlns:c16="http://schemas.microsoft.com/office/drawing/2014/chart" uri="{C3380CC4-5D6E-409C-BE32-E72D297353CC}">
-              <c16:uniqueId val="{00000028-C3C3-4350-AAB1-2820CDB871BA}"/>
+              <c16:uniqueId val="{00000028-E0BE-4FA6-853C-4CF059ECF56A}"/>
             </c:ext>
           </c:extLst>
         </c:ser>
@@ -729,7 +729,7 @@
             <c:bubble3D val="0"/>
             <c:extLst>
               <c:ext xmlns:c16="http://schemas.microsoft.com/office/drawing/2014/chart" uri="{C3380CC4-5D6E-409C-BE32-E72D297353CC}">
-                <c16:uniqueId val="{00000001-8A97-412E-AE60-BAC0811420D0}"/>
+                <c16:uniqueId val="{00000001-8196-4D85-8522-41F57CA25D35}"/>
               </c:ext>
             </c:extLst>
           </c:dPt>
@@ -739,7 +739,7 @@
             <c:bubble3D val="0"/>
             <c:extLst>
               <c:ext xmlns:c16="http://schemas.microsoft.com/office/drawing/2014/chart" uri="{C3380CC4-5D6E-409C-BE32-E72D297353CC}">
-                <c16:uniqueId val="{00000003-8A97-412E-AE60-BAC0811420D0}"/>
+                <c16:uniqueId val="{00000003-8196-4D85-8522-41F57CA25D35}"/>
               </c:ext>
             </c:extLst>
           </c:dPt>
@@ -755,7 +755,7 @@
             </c:spPr>
             <c:extLst>
               <c:ext xmlns:c16="http://schemas.microsoft.com/office/drawing/2014/chart" uri="{C3380CC4-5D6E-409C-BE32-E72D297353CC}">
-                <c16:uniqueId val="{00000005-8A97-412E-AE60-BAC0811420D0}"/>
+                <c16:uniqueId val="{00000005-8196-4D85-8522-41F57CA25D35}"/>
               </c:ext>
             </c:extLst>
           </c:dPt>
@@ -771,7 +771,7 @@
             </c:spPr>
             <c:extLst>
               <c:ext xmlns:c16="http://schemas.microsoft.com/office/drawing/2014/chart" uri="{C3380CC4-5D6E-409C-BE32-E72D297353CC}">
-                <c16:uniqueId val="{00000007-8A97-412E-AE60-BAC0811420D0}"/>
+                <c16:uniqueId val="{00000007-8196-4D85-8522-41F57CA25D35}"/>
               </c:ext>
             </c:extLst>
           </c:dPt>
@@ -787,7 +787,7 @@
             </c:spPr>
             <c:extLst>
               <c:ext xmlns:c16="http://schemas.microsoft.com/office/drawing/2014/chart" uri="{C3380CC4-5D6E-409C-BE32-E72D297353CC}">
-                <c16:uniqueId val="{00000009-8A97-412E-AE60-BAC0811420D0}"/>
+                <c16:uniqueId val="{00000009-8196-4D85-8522-41F57CA25D35}"/>
               </c:ext>
             </c:extLst>
           </c:dPt>
@@ -803,7 +803,7 @@
             </c:spPr>
             <c:extLst>
               <c:ext xmlns:c16="http://schemas.microsoft.com/office/drawing/2014/chart" uri="{C3380CC4-5D6E-409C-BE32-E72D297353CC}">
-                <c16:uniqueId val="{0000000B-8A97-412E-AE60-BAC0811420D0}"/>
+                <c16:uniqueId val="{0000000B-8196-4D85-8522-41F57CA25D35}"/>
               </c:ext>
             </c:extLst>
           </c:dPt>
@@ -819,7 +819,7 @@
             </c:spPr>
             <c:extLst>
               <c:ext xmlns:c16="http://schemas.microsoft.com/office/drawing/2014/chart" uri="{C3380CC4-5D6E-409C-BE32-E72D297353CC}">
-                <c16:uniqueId val="{0000000D-8A97-412E-AE60-BAC0811420D0}"/>
+                <c16:uniqueId val="{0000000D-8196-4D85-8522-41F57CA25D35}"/>
               </c:ext>
             </c:extLst>
           </c:dPt>
@@ -835,7 +835,7 @@
             </c:spPr>
             <c:extLst>
               <c:ext xmlns:c16="http://schemas.microsoft.com/office/drawing/2014/chart" uri="{C3380CC4-5D6E-409C-BE32-E72D297353CC}">
-                <c16:uniqueId val="{0000000F-8A97-412E-AE60-BAC0811420D0}"/>
+                <c16:uniqueId val="{0000000F-8196-4D85-8522-41F57CA25D35}"/>
               </c:ext>
             </c:extLst>
           </c:dPt>
@@ -851,7 +851,7 @@
             </c:spPr>
             <c:extLst>
               <c:ext xmlns:c16="http://schemas.microsoft.com/office/drawing/2014/chart" uri="{C3380CC4-5D6E-409C-BE32-E72D297353CC}">
-                <c16:uniqueId val="{00000011-8A97-412E-AE60-BAC0811420D0}"/>
+                <c16:uniqueId val="{00000011-8196-4D85-8522-41F57CA25D35}"/>
               </c:ext>
             </c:extLst>
           </c:dPt>
@@ -965,7 +965,7 @@
           </c:val>
           <c:extLst>
             <c:ext xmlns:c16="http://schemas.microsoft.com/office/drawing/2014/chart" uri="{C3380CC4-5D6E-409C-BE32-E72D297353CC}">
-              <c16:uniqueId val="{00000012-8A97-412E-AE60-BAC0811420D0}"/>
+              <c16:uniqueId val="{00000012-8196-4D85-8522-41F57CA25D35}"/>
             </c:ext>
           </c:extLst>
         </c:ser>
@@ -1209,7 +1209,7 @@
           <c:smooth val="0"/>
           <c:extLst>
             <c:ext xmlns:c16="http://schemas.microsoft.com/office/drawing/2014/chart" uri="{C3380CC4-5D6E-409C-BE32-E72D297353CC}">
-              <c16:uniqueId val="{00000000-49E8-4C68-9C56-5F4508731443}"/>
+              <c16:uniqueId val="{00000000-6E84-4BC2-8717-60EE017725D9}"/>
             </c:ext>
           </c:extLst>
         </c:ser>
@@ -1346,7 +1346,7 @@
           <c:smooth val="0"/>
           <c:extLst>
             <c:ext xmlns:c16="http://schemas.microsoft.com/office/drawing/2014/chart" uri="{C3380CC4-5D6E-409C-BE32-E72D297353CC}">
-              <c16:uniqueId val="{00000001-49E8-4C68-9C56-5F4508731443}"/>
+              <c16:uniqueId val="{00000001-6E84-4BC2-8717-60EE017725D9}"/>
             </c:ext>
           </c:extLst>
         </c:ser>
@@ -1552,7 +1552,7 @@
     </p:spTree>
     <p:extLst>
       <p:ext uri="{BB962C8B-B14F-4D97-AF65-F5344CB8AC3E}">
-        <p14:creationId xmlns:p14="http://schemas.microsoft.com/office/powerpoint/2010/main" val="1501845788"/>
+        <p14:creationId xmlns:p14="http://schemas.microsoft.com/office/powerpoint/2010/main" val="2766956316"/>
       </p:ext>
     </p:extLst>
   </p:cSld>
@@ -4481,7 +4481,7 @@
           <p:cNvPr id="25" name="s1 people">
             <a:extLst>
               <a:ext uri="{FF2B5EF4-FFF2-40B4-BE49-F238E27FC236}">
-                <a16:creationId xmlns:a16="http://schemas.microsoft.com/office/drawing/2014/main" id="{8D4294CE-0EC5-1CB5-3AD5-933DB84CEE5B}"/>
+                <a16:creationId xmlns:a16="http://schemas.microsoft.com/office/drawing/2014/main" id="{6B3E9AE4-3CEB-F7E1-C5D9-C51FED37D0B4}"/>
               </a:ext>
             </a:extLst>
           </p:cNvPr>
@@ -4580,7 +4580,7 @@
           <p:cNvPr id="26" name="s1 qr">
             <a:extLst>
               <a:ext uri="{FF2B5EF4-FFF2-40B4-BE49-F238E27FC236}">
-                <a16:creationId xmlns:a16="http://schemas.microsoft.com/office/drawing/2014/main" id="{4E9234B5-85D3-4134-3558-3724503D9622}"/>
+                <a16:creationId xmlns:a16="http://schemas.microsoft.com/office/drawing/2014/main" id="{47E98001-49AB-3E72-3485-4F0C5E5AAC20}"/>
               </a:ext>
             </a:extLst>
           </p:cNvPr>
@@ -6229,7 +6229,7 @@
           <p:cNvPr id="45" name="s10 card0">
             <a:extLst>
               <a:ext uri="{FF2B5EF4-FFF2-40B4-BE49-F238E27FC236}">
-                <a16:creationId xmlns:a16="http://schemas.microsoft.com/office/drawing/2014/main" id="{45DC62A8-5C5C-DE2A-F0BD-EF28617EE244}"/>
+                <a16:creationId xmlns:a16="http://schemas.microsoft.com/office/drawing/2014/main" id="{D8069DE5-AF12-7421-04C3-2C87F9FF5896}"/>
               </a:ext>
             </a:extLst>
           </p:cNvPr>
@@ -6447,7 +6447,7 @@
           <p:cNvPr id="46" name="s10 card1">
             <a:extLst>
               <a:ext uri="{FF2B5EF4-FFF2-40B4-BE49-F238E27FC236}">
-                <a16:creationId xmlns:a16="http://schemas.microsoft.com/office/drawing/2014/main" id="{8C17C7AC-DB7E-8A25-E9E1-D9496F0B41BA}"/>
+                <a16:creationId xmlns:a16="http://schemas.microsoft.com/office/drawing/2014/main" id="{F399F3AA-35F3-ADBF-DCAE-82A451B4ADBF}"/>
               </a:ext>
             </a:extLst>
           </p:cNvPr>
@@ -6665,7 +6665,7 @@
           <p:cNvPr id="47" name="s10 card2">
             <a:extLst>
               <a:ext uri="{FF2B5EF4-FFF2-40B4-BE49-F238E27FC236}">
-                <a16:creationId xmlns:a16="http://schemas.microsoft.com/office/drawing/2014/main" id="{CD9E75F4-A9B5-B7E1-42E3-BEF9FCE7F558}"/>
+                <a16:creationId xmlns:a16="http://schemas.microsoft.com/office/drawing/2014/main" id="{B6E49525-1FBC-3B34-59BF-CC906EF84D05}"/>
               </a:ext>
             </a:extLst>
           </p:cNvPr>
@@ -6883,7 +6883,7 @@
           <p:cNvPr id="48" name="s10 card3">
             <a:extLst>
               <a:ext uri="{FF2B5EF4-FFF2-40B4-BE49-F238E27FC236}">
-                <a16:creationId xmlns:a16="http://schemas.microsoft.com/office/drawing/2014/main" id="{E0CE06A9-759B-A144-12F2-85DEDA87A5A0}"/>
+                <a16:creationId xmlns:a16="http://schemas.microsoft.com/office/drawing/2014/main" id="{DC298263-2A77-4303-0551-4A788C767C33}"/>
               </a:ext>
             </a:extLst>
           </p:cNvPr>
@@ -8207,7 +8207,7 @@
           <p:cNvPr id="69" name="s11 tileA">
             <a:extLst>
               <a:ext uri="{FF2B5EF4-FFF2-40B4-BE49-F238E27FC236}">
-                <a16:creationId xmlns:a16="http://schemas.microsoft.com/office/drawing/2014/main" id="{4F5AA925-E533-2C4C-5DE3-6C9FF9D464EF}"/>
+                <a16:creationId xmlns:a16="http://schemas.microsoft.com/office/drawing/2014/main" id="{FC7DA7B3-5346-F2BD-400C-58E1BD1854D5}"/>
               </a:ext>
             </a:extLst>
           </p:cNvPr>
@@ -8374,7 +8374,7 @@
           <p:cNvPr id="70" name="s11 tileB">
             <a:extLst>
               <a:ext uri="{FF2B5EF4-FFF2-40B4-BE49-F238E27FC236}">
-                <a16:creationId xmlns:a16="http://schemas.microsoft.com/office/drawing/2014/main" id="{480F1C02-254C-878F-EB27-B1D597715C1D}"/>
+                <a16:creationId xmlns:a16="http://schemas.microsoft.com/office/drawing/2014/main" id="{ED3BC712-5FEA-9815-E04D-F68DE5334235}"/>
               </a:ext>
             </a:extLst>
           </p:cNvPr>
@@ -8541,7 +8541,7 @@
           <p:cNvPr id="71" name="s11 panel">
             <a:extLst>
               <a:ext uri="{FF2B5EF4-FFF2-40B4-BE49-F238E27FC236}">
-                <a16:creationId xmlns:a16="http://schemas.microsoft.com/office/drawing/2014/main" id="{4BA0C9AA-4D76-3761-B5B3-F9966369E5D6}"/>
+                <a16:creationId xmlns:a16="http://schemas.microsoft.com/office/drawing/2014/main" id="{08E55699-4673-1DA8-BFA8-4FC2177C79EB}"/>
               </a:ext>
             </a:extLst>
           </p:cNvPr>
@@ -8630,7 +8630,7 @@
           <p:cNvPr id="72" name="s11 step1">
             <a:extLst>
               <a:ext uri="{FF2B5EF4-FFF2-40B4-BE49-F238E27FC236}">
-                <a16:creationId xmlns:a16="http://schemas.microsoft.com/office/drawing/2014/main" id="{913CA773-5452-EB07-3581-4C338E1279DC}"/>
+                <a16:creationId xmlns:a16="http://schemas.microsoft.com/office/drawing/2014/main" id="{A2A820C3-111C-23DA-91AF-2E54AF3FB311}"/>
               </a:ext>
             </a:extLst>
           </p:cNvPr>
@@ -9180,7 +9180,7 @@
           <p:cNvPr id="73" name="s11 step2">
             <a:extLst>
               <a:ext uri="{FF2B5EF4-FFF2-40B4-BE49-F238E27FC236}">
-                <a16:creationId xmlns:a16="http://schemas.microsoft.com/office/drawing/2014/main" id="{8B119E44-E80E-E80F-2E37-D819974C9BBF}"/>
+                <a16:creationId xmlns:a16="http://schemas.microsoft.com/office/drawing/2014/main" id="{D26B3CDF-9F5D-EDD4-7A3B-F407156CB4F2}"/>
               </a:ext>
             </a:extLst>
           </p:cNvPr>
@@ -9474,7 +9474,7 @@
           <p:cNvPr id="74" name="s11 step3">
             <a:extLst>
               <a:ext uri="{FF2B5EF4-FFF2-40B4-BE49-F238E27FC236}">
-                <a16:creationId xmlns:a16="http://schemas.microsoft.com/office/drawing/2014/main" id="{C3747A8A-898B-C317-BF39-C714D98E6FC0}"/>
+                <a16:creationId xmlns:a16="http://schemas.microsoft.com/office/drawing/2014/main" id="{5B52A5B5-68C3-8A78-282E-016D49B95078}"/>
               </a:ext>
             </a:extLst>
           </p:cNvPr>
@@ -11035,7 +11035,7 @@
           <p:cNvPr id="37" name="s12 lesson0">
             <a:extLst>
               <a:ext uri="{FF2B5EF4-FFF2-40B4-BE49-F238E27FC236}">
-                <a16:creationId xmlns:a16="http://schemas.microsoft.com/office/drawing/2014/main" id="{77737B05-EF20-B7DA-7B19-372568F23CFB}"/>
+                <a16:creationId xmlns:a16="http://schemas.microsoft.com/office/drawing/2014/main" id="{86D8FD74-EFE7-C0AA-D441-DA8F9DBE13C2}"/>
               </a:ext>
             </a:extLst>
           </p:cNvPr>
@@ -11227,7 +11227,7 @@
           <p:cNvPr id="38" name="s12 lesson1">
             <a:extLst>
               <a:ext uri="{FF2B5EF4-FFF2-40B4-BE49-F238E27FC236}">
-                <a16:creationId xmlns:a16="http://schemas.microsoft.com/office/drawing/2014/main" id="{B48D5E4E-7ED1-9037-E819-EB17FC1894CA}"/>
+                <a16:creationId xmlns:a16="http://schemas.microsoft.com/office/drawing/2014/main" id="{C5F0DC3D-6563-41BA-BD5A-2295F5633D50}"/>
               </a:ext>
             </a:extLst>
           </p:cNvPr>
@@ -11419,7 +11419,7 @@
           <p:cNvPr id="39" name="s12 lesson2">
             <a:extLst>
               <a:ext uri="{FF2B5EF4-FFF2-40B4-BE49-F238E27FC236}">
-                <a16:creationId xmlns:a16="http://schemas.microsoft.com/office/drawing/2014/main" id="{1187A734-3C74-FB8E-AE0A-EC5823EEB143}"/>
+                <a16:creationId xmlns:a16="http://schemas.microsoft.com/office/drawing/2014/main" id="{E4537C82-4E70-652C-2887-34D81EBCDC77}"/>
               </a:ext>
             </a:extLst>
           </p:cNvPr>
@@ -11611,7 +11611,7 @@
           <p:cNvPr id="40" name="s12 limits">
             <a:extLst>
               <a:ext uri="{FF2B5EF4-FFF2-40B4-BE49-F238E27FC236}">
-                <a16:creationId xmlns:a16="http://schemas.microsoft.com/office/drawing/2014/main" id="{21CA45B3-7FC8-5099-57F3-DE303ADAF294}"/>
+                <a16:creationId xmlns:a16="http://schemas.microsoft.com/office/drawing/2014/main" id="{B0A00DF4-2528-F06B-FC71-C2F960CADA9C}"/>
               </a:ext>
             </a:extLst>
           </p:cNvPr>
@@ -12770,7 +12770,7 @@
           <p:cNvPr id="32" name="s13 qrs">
             <a:extLst>
               <a:ext uri="{FF2B5EF4-FFF2-40B4-BE49-F238E27FC236}">
-                <a16:creationId xmlns:a16="http://schemas.microsoft.com/office/drawing/2014/main" id="{5803A663-0C11-B3E3-74F0-B26EE25222CA}"/>
+                <a16:creationId xmlns:a16="http://schemas.microsoft.com/office/drawing/2014/main" id="{03812A47-8252-E022-6DDC-FB6454381825}"/>
               </a:ext>
             </a:extLst>
           </p:cNvPr>
@@ -13018,7 +13018,7 @@
           <p:cNvPr id="33" name="s13 nav">
             <a:extLst>
               <a:ext uri="{FF2B5EF4-FFF2-40B4-BE49-F238E27FC236}">
-                <a16:creationId xmlns:a16="http://schemas.microsoft.com/office/drawing/2014/main" id="{65D3D77B-AC43-5AE3-EA42-5E6B22F88569}"/>
+                <a16:creationId xmlns:a16="http://schemas.microsoft.com/office/drawing/2014/main" id="{7747A624-A919-CEAC-49E2-2BCD50354506}"/>
               </a:ext>
             </a:extLst>
           </p:cNvPr>
@@ -14368,7 +14368,7 @@
           <p:cNvPr id="26" name="s14 t1">
             <a:extLst>
               <a:ext uri="{FF2B5EF4-FFF2-40B4-BE49-F238E27FC236}">
-                <a16:creationId xmlns:a16="http://schemas.microsoft.com/office/drawing/2014/main" id="{DB173E56-5350-BE86-BAF4-D52D1AA9015F}"/>
+                <a16:creationId xmlns:a16="http://schemas.microsoft.com/office/drawing/2014/main" id="{A60A4DA4-D6FE-52D3-0BA7-5F9B393FFF6D}"/>
               </a:ext>
             </a:extLst>
           </p:cNvPr>
@@ -14535,7 +14535,7 @@
           <p:cNvPr id="27" name="s14 t2">
             <a:extLst>
               <a:ext uri="{FF2B5EF4-FFF2-40B4-BE49-F238E27FC236}">
-                <a16:creationId xmlns:a16="http://schemas.microsoft.com/office/drawing/2014/main" id="{BB3668AC-B66C-411D-8907-B45F99A887FB}"/>
+                <a16:creationId xmlns:a16="http://schemas.microsoft.com/office/drawing/2014/main" id="{47C7ADCF-83FD-6351-73AF-0B4BC03161B1}"/>
               </a:ext>
             </a:extLst>
           </p:cNvPr>
@@ -14702,7 +14702,7 @@
           <p:cNvPr id="28" name="s14 t3">
             <a:extLst>
               <a:ext uri="{FF2B5EF4-FFF2-40B4-BE49-F238E27FC236}">
-                <a16:creationId xmlns:a16="http://schemas.microsoft.com/office/drawing/2014/main" id="{364D28F0-3404-9AD7-57C0-F9130E9F96F4}"/>
+                <a16:creationId xmlns:a16="http://schemas.microsoft.com/office/drawing/2014/main" id="{F1E7F1E7-3AD5-D9C7-FC49-3BB1D8D39CF8}"/>
               </a:ext>
             </a:extLst>
           </p:cNvPr>
@@ -19561,7 +19561,7 @@
           <p:cNvPr id="28" name="s16 t1">
             <a:extLst>
               <a:ext uri="{FF2B5EF4-FFF2-40B4-BE49-F238E27FC236}">
-                <a16:creationId xmlns:a16="http://schemas.microsoft.com/office/drawing/2014/main" id="{520341FE-4D23-96FF-2D02-4A7C3751AA7B}"/>
+                <a16:creationId xmlns:a16="http://schemas.microsoft.com/office/drawing/2014/main" id="{E47DBB44-051B-D3E6-4563-572FDBE570C3}"/>
               </a:ext>
             </a:extLst>
           </p:cNvPr>
@@ -19728,7 +19728,7 @@
           <p:cNvPr id="29" name="s16 t2">
             <a:extLst>
               <a:ext uri="{FF2B5EF4-FFF2-40B4-BE49-F238E27FC236}">
-                <a16:creationId xmlns:a16="http://schemas.microsoft.com/office/drawing/2014/main" id="{96AC3824-2553-89C1-94F6-611E5AC424FE}"/>
+                <a16:creationId xmlns:a16="http://schemas.microsoft.com/office/drawing/2014/main" id="{EC5980E1-DE26-38C4-30C8-514EF5FD60DE}"/>
               </a:ext>
             </a:extLst>
           </p:cNvPr>
@@ -19895,7 +19895,7 @@
           <p:cNvPr id="30" name="s16 t3">
             <a:extLst>
               <a:ext uri="{FF2B5EF4-FFF2-40B4-BE49-F238E27FC236}">
-                <a16:creationId xmlns:a16="http://schemas.microsoft.com/office/drawing/2014/main" id="{3E4236F2-689A-FAB8-5A15-CFF468A4CE16}"/>
+                <a16:creationId xmlns:a16="http://schemas.microsoft.com/office/drawing/2014/main" id="{0F02A9A6-B7B3-8706-37E7-B0FCA162708B}"/>
               </a:ext>
             </a:extLst>
           </p:cNvPr>
@@ -20338,7 +20338,7 @@
           <p:cNvPr id="21" name="s17 t1">
             <a:extLst>
               <a:ext uri="{FF2B5EF4-FFF2-40B4-BE49-F238E27FC236}">
-                <a16:creationId xmlns:a16="http://schemas.microsoft.com/office/drawing/2014/main" id="{0DCBF6FD-18FB-DDC6-4945-B72BBCD7B679}"/>
+                <a16:creationId xmlns:a16="http://schemas.microsoft.com/office/drawing/2014/main" id="{5C55D57D-2C8D-CBAA-187E-64763E70B304}"/>
               </a:ext>
             </a:extLst>
           </p:cNvPr>
@@ -20505,7 +20505,7 @@
           <p:cNvPr id="22" name="s17 t2">
             <a:extLst>
               <a:ext uri="{FF2B5EF4-FFF2-40B4-BE49-F238E27FC236}">
-                <a16:creationId xmlns:a16="http://schemas.microsoft.com/office/drawing/2014/main" id="{CC86C1C5-EBE2-8CAF-A860-A348BC63AE77}"/>
+                <a16:creationId xmlns:a16="http://schemas.microsoft.com/office/drawing/2014/main" id="{6D7D1A2A-B7C9-98E6-9590-CA94146D13CE}"/>
               </a:ext>
             </a:extLst>
           </p:cNvPr>
@@ -20672,7 +20672,7 @@
           <p:cNvPr id="23" name="s17 t3">
             <a:extLst>
               <a:ext uri="{FF2B5EF4-FFF2-40B4-BE49-F238E27FC236}">
-                <a16:creationId xmlns:a16="http://schemas.microsoft.com/office/drawing/2014/main" id="{023123F0-A568-2A23-5436-B3105E7EDE70}"/>
+                <a16:creationId xmlns:a16="http://schemas.microsoft.com/office/drawing/2014/main" id="{802E9201-83C3-5D71-6DDC-F14517CB0663}"/>
               </a:ext>
             </a:extLst>
           </p:cNvPr>
@@ -21076,7 +21076,7 @@
           <p:cNvPr id="20" name="s18 t1">
             <a:extLst>
               <a:ext uri="{FF2B5EF4-FFF2-40B4-BE49-F238E27FC236}">
-                <a16:creationId xmlns:a16="http://schemas.microsoft.com/office/drawing/2014/main" id="{B4AC25EF-A5E5-5BA5-1189-ABA5975FB5A2}"/>
+                <a16:creationId xmlns:a16="http://schemas.microsoft.com/office/drawing/2014/main" id="{79EA9CF4-B831-C171-B30D-205DCC2AEBDB}"/>
               </a:ext>
             </a:extLst>
           </p:cNvPr>
@@ -21243,7 +21243,7 @@
           <p:cNvPr id="21" name="s18 t2">
             <a:extLst>
               <a:ext uri="{FF2B5EF4-FFF2-40B4-BE49-F238E27FC236}">
-                <a16:creationId xmlns:a16="http://schemas.microsoft.com/office/drawing/2014/main" id="{CF9CF920-4EC7-D0E1-1674-4D4414A30B1E}"/>
+                <a16:creationId xmlns:a16="http://schemas.microsoft.com/office/drawing/2014/main" id="{E8188E76-5474-A0F5-929E-1E0C1061BD11}"/>
               </a:ext>
             </a:extLst>
           </p:cNvPr>
@@ -21410,7 +21410,7 @@
           <p:cNvPr id="22" name="s18 t3">
             <a:extLst>
               <a:ext uri="{FF2B5EF4-FFF2-40B4-BE49-F238E27FC236}">
-                <a16:creationId xmlns:a16="http://schemas.microsoft.com/office/drawing/2014/main" id="{03CA3A06-E6C0-4CCA-A786-1E4BC214DFA2}"/>
+                <a16:creationId xmlns:a16="http://schemas.microsoft.com/office/drawing/2014/main" id="{4C49480F-2ABB-5042-FFFE-8D5787E7FD6A}"/>
               </a:ext>
             </a:extLst>
           </p:cNvPr>
@@ -23501,7 +23501,7 @@
           <p:cNvPr id="6" name="s19 t1">
             <a:extLst>
               <a:ext uri="{FF2B5EF4-FFF2-40B4-BE49-F238E27FC236}">
-                <a16:creationId xmlns:a16="http://schemas.microsoft.com/office/drawing/2014/main" id="{D7113B07-88D5-863B-E7E3-50A3883274AE}"/>
+                <a16:creationId xmlns:a16="http://schemas.microsoft.com/office/drawing/2014/main" id="{452F3993-848D-92DE-6756-7C07D4FC410E}"/>
               </a:ext>
             </a:extLst>
           </p:cNvPr>
@@ -23668,7 +23668,7 @@
           <p:cNvPr id="19" name="s19 t2">
             <a:extLst>
               <a:ext uri="{FF2B5EF4-FFF2-40B4-BE49-F238E27FC236}">
-                <a16:creationId xmlns:a16="http://schemas.microsoft.com/office/drawing/2014/main" id="{775759D3-0EB7-7901-78A9-9292877F2D26}"/>
+                <a16:creationId xmlns:a16="http://schemas.microsoft.com/office/drawing/2014/main" id="{769258B6-4962-036A-87C2-1ECB9428732D}"/>
               </a:ext>
             </a:extLst>
           </p:cNvPr>
@@ -23835,7 +23835,7 @@
           <p:cNvPr id="21" name="s19 t3">
             <a:extLst>
               <a:ext uri="{FF2B5EF4-FFF2-40B4-BE49-F238E27FC236}">
-                <a16:creationId xmlns:a16="http://schemas.microsoft.com/office/drawing/2014/main" id="{DD37BF78-AE83-F30A-0783-7BE0FF864467}"/>
+                <a16:creationId xmlns:a16="http://schemas.microsoft.com/office/drawing/2014/main" id="{3B5C9297-7F79-648A-966E-2B414DF4439E}"/>
               </a:ext>
             </a:extLst>
           </p:cNvPr>
@@ -24171,7 +24171,7 @@
           <p:cNvPr id="43" name="s2 places">
             <a:extLst>
               <a:ext uri="{FF2B5EF4-FFF2-40B4-BE49-F238E27FC236}">
-                <a16:creationId xmlns:a16="http://schemas.microsoft.com/office/drawing/2014/main" id="{7EFFCE79-9863-4563-8C75-653E124F6034}"/>
+                <a16:creationId xmlns:a16="http://schemas.microsoft.com/office/drawing/2014/main" id="{50C91DED-D214-C6FC-9EF7-8E470B19762F}"/>
               </a:ext>
             </a:extLst>
           </p:cNvPr>
@@ -24436,7 +24436,7 @@
           <p:cNvPr id="38" name="s2 row0">
             <a:extLst>
               <a:ext uri="{FF2B5EF4-FFF2-40B4-BE49-F238E27FC236}">
-                <a16:creationId xmlns:a16="http://schemas.microsoft.com/office/drawing/2014/main" id="{4454B862-3EAA-4121-1A1E-5C6D6AACB76B}"/>
+                <a16:creationId xmlns:a16="http://schemas.microsoft.com/office/drawing/2014/main" id="{1A4B039E-19FD-2371-1CED-00FECA820F08}"/>
               </a:ext>
             </a:extLst>
           </p:cNvPr>
@@ -24595,7 +24595,7 @@
           <p:cNvPr id="39" name="s2 row1">
             <a:extLst>
               <a:ext uri="{FF2B5EF4-FFF2-40B4-BE49-F238E27FC236}">
-                <a16:creationId xmlns:a16="http://schemas.microsoft.com/office/drawing/2014/main" id="{301CE457-0E60-896F-59A2-2DBD97ACF164}"/>
+                <a16:creationId xmlns:a16="http://schemas.microsoft.com/office/drawing/2014/main" id="{DBFDD1A0-4352-D3A7-05B1-C5061301C5F2}"/>
               </a:ext>
             </a:extLst>
           </p:cNvPr>
@@ -24705,7 +24705,7 @@
           <p:cNvPr id="40" name="s2 row2">
             <a:extLst>
               <a:ext uri="{FF2B5EF4-FFF2-40B4-BE49-F238E27FC236}">
-                <a16:creationId xmlns:a16="http://schemas.microsoft.com/office/drawing/2014/main" id="{13432DC2-FAEA-FDD1-AC07-593DDBDA32A2}"/>
+                <a16:creationId xmlns:a16="http://schemas.microsoft.com/office/drawing/2014/main" id="{B9732533-8D82-7479-FA98-310244B3B8F3}"/>
               </a:ext>
             </a:extLst>
           </p:cNvPr>
@@ -24913,7 +24913,7 @@
           <p:cNvPr id="41" name="s2 row3">
             <a:extLst>
               <a:ext uri="{FF2B5EF4-FFF2-40B4-BE49-F238E27FC236}">
-                <a16:creationId xmlns:a16="http://schemas.microsoft.com/office/drawing/2014/main" id="{819C723D-71F9-1575-51F0-43F687ED586E}"/>
+                <a16:creationId xmlns:a16="http://schemas.microsoft.com/office/drawing/2014/main" id="{1DD10636-7AB6-9CA9-4FE4-6B690F1B2A69}"/>
               </a:ext>
             </a:extLst>
           </p:cNvPr>
@@ -25072,7 +25072,7 @@
           <p:cNvPr id="42" name="s2 row4">
             <a:extLst>
               <a:ext uri="{FF2B5EF4-FFF2-40B4-BE49-F238E27FC236}">
-                <a16:creationId xmlns:a16="http://schemas.microsoft.com/office/drawing/2014/main" id="{AC61B452-3051-F16F-D1FF-E8DD2DDF4EA7}"/>
+                <a16:creationId xmlns:a16="http://schemas.microsoft.com/office/drawing/2014/main" id="{C0298B2C-0E62-7D5A-1D76-90E3B7DF701F}"/>
               </a:ext>
             </a:extLst>
           </p:cNvPr>
@@ -28229,7 +28229,7 @@
           <p:cNvPr id="69" name="s3 numbers">
             <a:extLst>
               <a:ext uri="{FF2B5EF4-FFF2-40B4-BE49-F238E27FC236}">
-                <a16:creationId xmlns:a16="http://schemas.microsoft.com/office/drawing/2014/main" id="{EDF59B4E-35A3-EC87-2E42-5C73B85F87DD}"/>
+                <a16:creationId xmlns:a16="http://schemas.microsoft.com/office/drawing/2014/main" id="{0C8AD1B3-C9CA-12F0-60E4-7E129C1AE978}"/>
               </a:ext>
             </a:extLst>
           </p:cNvPr>
@@ -28484,7 +28484,7 @@
           <p:cNvPr id="59" name="s3 cite">
             <a:extLst>
               <a:ext uri="{FF2B5EF4-FFF2-40B4-BE49-F238E27FC236}">
-                <a16:creationId xmlns:a16="http://schemas.microsoft.com/office/drawing/2014/main" id="{117FD374-8AE8-D38C-F1A6-82B74E00617C}"/>
+                <a16:creationId xmlns:a16="http://schemas.microsoft.com/office/drawing/2014/main" id="{2AE5157D-F1A8-2C13-D250-0C7787727F3B}"/>
               </a:ext>
             </a:extLst>
           </p:cNvPr>
@@ -28617,7 +28617,7 @@
           <p:cNvPr id="70" name="s3 chartcard">
             <a:extLst>
               <a:ext uri="{FF2B5EF4-FFF2-40B4-BE49-F238E27FC236}">
-                <a16:creationId xmlns:a16="http://schemas.microsoft.com/office/drawing/2014/main" id="{EB73BC80-909F-BC07-B7BD-B1FB9E175ED7}"/>
+                <a16:creationId xmlns:a16="http://schemas.microsoft.com/office/drawing/2014/main" id="{48CE08CC-B12C-34A0-F6B1-3FB539BFEF73}"/>
               </a:ext>
             </a:extLst>
           </p:cNvPr>
@@ -28711,7 +28711,7 @@
           <p:cNvPr id="66" name="s3 cats">
             <a:extLst>
               <a:ext uri="{FF2B5EF4-FFF2-40B4-BE49-F238E27FC236}">
-                <a16:creationId xmlns:a16="http://schemas.microsoft.com/office/drawing/2014/main" id="{01F62DDE-5A0E-6557-2AF4-04BA543BADAB}"/>
+                <a16:creationId xmlns:a16="http://schemas.microsoft.com/office/drawing/2014/main" id="{D28F2316-E338-F85D-9F78-C74EF8B2CD14}"/>
               </a:ext>
             </a:extLst>
           </p:cNvPr>
@@ -29091,7 +29091,7 @@
           <p:cNvPr id="60" name="s3 bar0">
             <a:extLst>
               <a:ext uri="{FF2B5EF4-FFF2-40B4-BE49-F238E27FC236}">
-                <a16:creationId xmlns:a16="http://schemas.microsoft.com/office/drawing/2014/main" id="{38D722C3-2B3B-1EC1-B192-615397A13BD5}"/>
+                <a16:creationId xmlns:a16="http://schemas.microsoft.com/office/drawing/2014/main" id="{8D40284E-BD6E-3EA3-973F-4522CF02DFF0}"/>
               </a:ext>
             </a:extLst>
           </p:cNvPr>
@@ -29180,7 +29180,7 @@
           <p:cNvPr id="61" name="s3 bar1">
             <a:extLst>
               <a:ext uri="{FF2B5EF4-FFF2-40B4-BE49-F238E27FC236}">
-                <a16:creationId xmlns:a16="http://schemas.microsoft.com/office/drawing/2014/main" id="{D7279FF5-AB2A-A08B-50A1-A0D48C177273}"/>
+                <a16:creationId xmlns:a16="http://schemas.microsoft.com/office/drawing/2014/main" id="{59C98733-C68B-619D-374E-306A0352DFE2}"/>
               </a:ext>
             </a:extLst>
           </p:cNvPr>
@@ -29269,7 +29269,7 @@
           <p:cNvPr id="62" name="s3 bar2">
             <a:extLst>
               <a:ext uri="{FF2B5EF4-FFF2-40B4-BE49-F238E27FC236}">
-                <a16:creationId xmlns:a16="http://schemas.microsoft.com/office/drawing/2014/main" id="{8D6F76EC-A236-DBB0-808F-FD7C87B50D1C}"/>
+                <a16:creationId xmlns:a16="http://schemas.microsoft.com/office/drawing/2014/main" id="{DFAC29E6-5E39-8536-C824-2B04F4699131}"/>
               </a:ext>
             </a:extLst>
           </p:cNvPr>
@@ -29358,7 +29358,7 @@
           <p:cNvPr id="63" name="s3 bar3">
             <a:extLst>
               <a:ext uri="{FF2B5EF4-FFF2-40B4-BE49-F238E27FC236}">
-                <a16:creationId xmlns:a16="http://schemas.microsoft.com/office/drawing/2014/main" id="{42B4D11C-3E46-513F-1AC6-53BCC40FBA1C}"/>
+                <a16:creationId xmlns:a16="http://schemas.microsoft.com/office/drawing/2014/main" id="{2BECB794-6B68-6AA6-7856-84418A056344}"/>
               </a:ext>
             </a:extLst>
           </p:cNvPr>
@@ -29447,7 +29447,7 @@
           <p:cNvPr id="64" name="s3 bar4">
             <a:extLst>
               <a:ext uri="{FF2B5EF4-FFF2-40B4-BE49-F238E27FC236}">
-                <a16:creationId xmlns:a16="http://schemas.microsoft.com/office/drawing/2014/main" id="{A66B6CE2-C209-6F52-4E6D-D89E06501556}"/>
+                <a16:creationId xmlns:a16="http://schemas.microsoft.com/office/drawing/2014/main" id="{C15490BE-C70D-4D1A-AECC-AB6459FD05FD}"/>
               </a:ext>
             </a:extLst>
           </p:cNvPr>
@@ -29536,7 +29536,7 @@
           <p:cNvPr id="65" name="s3 bar5">
             <a:extLst>
               <a:ext uri="{FF2B5EF4-FFF2-40B4-BE49-F238E27FC236}">
-                <a16:creationId xmlns:a16="http://schemas.microsoft.com/office/drawing/2014/main" id="{F5624389-6CBE-98BA-E2DF-9CF123484410}"/>
+                <a16:creationId xmlns:a16="http://schemas.microsoft.com/office/drawing/2014/main" id="{B3288227-8A88-08B9-FA66-0D425F42255B}"/>
               </a:ext>
             </a:extLst>
           </p:cNvPr>
@@ -29625,7 +29625,7 @@
           <p:cNvPr id="67" name="s3 tileA">
             <a:extLst>
               <a:ext uri="{FF2B5EF4-FFF2-40B4-BE49-F238E27FC236}">
-                <a16:creationId xmlns:a16="http://schemas.microsoft.com/office/drawing/2014/main" id="{5E7F6379-DDFF-C4B8-86EE-EDB1407BBE84}"/>
+                <a16:creationId xmlns:a16="http://schemas.microsoft.com/office/drawing/2014/main" id="{896C717D-CD44-DBA4-7EBC-92F9AA88AE8B}"/>
               </a:ext>
             </a:extLst>
           </p:cNvPr>
@@ -29792,7 +29792,7 @@
           <p:cNvPr id="68" name="s3 tileB">
             <a:extLst>
               <a:ext uri="{FF2B5EF4-FFF2-40B4-BE49-F238E27FC236}">
-                <a16:creationId xmlns:a16="http://schemas.microsoft.com/office/drawing/2014/main" id="{E800F914-AE85-4A71-0E81-E40A35AB0426}"/>
+                <a16:creationId xmlns:a16="http://schemas.microsoft.com/office/drawing/2014/main" id="{EC4B9B42-81B5-93C2-70C2-0C502F20D3C4}"/>
               </a:ext>
             </a:extLst>
           </p:cNvPr>
@@ -31223,7 +31223,7 @@
           <p:cNvPr id="45" name="s4 stages">
             <a:extLst>
               <a:ext uri="{FF2B5EF4-FFF2-40B4-BE49-F238E27FC236}">
-                <a16:creationId xmlns:a16="http://schemas.microsoft.com/office/drawing/2014/main" id="{D51772E5-1B59-8973-6EE9-5EBA5089F0A7}"/>
+                <a16:creationId xmlns:a16="http://schemas.microsoft.com/office/drawing/2014/main" id="{4DDF2153-BBBD-A197-68EE-06850E617497}"/>
               </a:ext>
             </a:extLst>
           </p:cNvPr>
@@ -31547,7 +31547,7 @@
           <p:cNvPr id="42" name="s4 card0">
             <a:extLst>
               <a:ext uri="{FF2B5EF4-FFF2-40B4-BE49-F238E27FC236}">
-                <a16:creationId xmlns:a16="http://schemas.microsoft.com/office/drawing/2014/main" id="{E7059E37-5FFB-8F99-108A-00FAF7D92C6F}"/>
+                <a16:creationId xmlns:a16="http://schemas.microsoft.com/office/drawing/2014/main" id="{9D41E006-7C47-D17F-09EF-401A96B7C1E9}"/>
               </a:ext>
             </a:extLst>
           </p:cNvPr>
@@ -31753,7 +31753,7 @@
           <p:cNvPr id="43" name="s4 card1">
             <a:extLst>
               <a:ext uri="{FF2B5EF4-FFF2-40B4-BE49-F238E27FC236}">
-                <a16:creationId xmlns:a16="http://schemas.microsoft.com/office/drawing/2014/main" id="{7C255228-2ACF-DF0D-A988-65FF468280B4}"/>
+                <a16:creationId xmlns:a16="http://schemas.microsoft.com/office/drawing/2014/main" id="{AEE03F47-DC34-F86F-152A-B6F55D504B28}"/>
               </a:ext>
             </a:extLst>
           </p:cNvPr>
@@ -31959,7 +31959,7 @@
           <p:cNvPr id="44" name="s4 card2">
             <a:extLst>
               <a:ext uri="{FF2B5EF4-FFF2-40B4-BE49-F238E27FC236}">
-                <a16:creationId xmlns:a16="http://schemas.microsoft.com/office/drawing/2014/main" id="{88BF2333-86DE-973B-989D-F26668DB8CD4}"/>
+                <a16:creationId xmlns:a16="http://schemas.microsoft.com/office/drawing/2014/main" id="{242DC171-1780-A1EA-6064-00793A91B330}"/>
               </a:ext>
             </a:extLst>
           </p:cNvPr>
@@ -32165,7 +32165,7 @@
           <p:cNvPr id="46" name="s4 review">
             <a:extLst>
               <a:ext uri="{FF2B5EF4-FFF2-40B4-BE49-F238E27FC236}">
-                <a16:creationId xmlns:a16="http://schemas.microsoft.com/office/drawing/2014/main" id="{61B69B2B-C69B-D3B5-0F8E-55D363FB6C74}"/>
+                <a16:creationId xmlns:a16="http://schemas.microsoft.com/office/drawing/2014/main" id="{5194E815-C3D9-B97C-2C27-7F746AC6A877}"/>
               </a:ext>
             </a:extLst>
           </p:cNvPr>
@@ -33358,7 +33358,7 @@
           <p:cNvPr id="38" name="s5 panel">
             <a:extLst>
               <a:ext uri="{FF2B5EF4-FFF2-40B4-BE49-F238E27FC236}">
-                <a16:creationId xmlns:a16="http://schemas.microsoft.com/office/drawing/2014/main" id="{9B23EBCC-8F3D-5ACF-9152-FDB6643F5EEA}"/>
+                <a16:creationId xmlns:a16="http://schemas.microsoft.com/office/drawing/2014/main" id="{6184078F-481F-C39F-0336-46EC087B876D}"/>
               </a:ext>
             </a:extLst>
           </p:cNvPr>
@@ -33516,7 +33516,7 @@
           <p:cNvPr id="35" name="s5 row0">
             <a:extLst>
               <a:ext uri="{FF2B5EF4-FFF2-40B4-BE49-F238E27FC236}">
-                <a16:creationId xmlns:a16="http://schemas.microsoft.com/office/drawing/2014/main" id="{3371FACF-5C89-BEA7-C211-E5ACDE15A6BF}"/>
+                <a16:creationId xmlns:a16="http://schemas.microsoft.com/office/drawing/2014/main" id="{DF27D5A4-F2C7-D9D1-E54F-9140BEA8C1D9}"/>
               </a:ext>
             </a:extLst>
           </p:cNvPr>
@@ -33664,7 +33664,7 @@
           <p:cNvPr id="36" name="s5 row1">
             <a:extLst>
               <a:ext uri="{FF2B5EF4-FFF2-40B4-BE49-F238E27FC236}">
-                <a16:creationId xmlns:a16="http://schemas.microsoft.com/office/drawing/2014/main" id="{24C8DDEF-277B-0FC8-C97B-C87088E34238}"/>
+                <a16:creationId xmlns:a16="http://schemas.microsoft.com/office/drawing/2014/main" id="{EF1750ED-5230-1C94-F57C-96638F039A2E}"/>
               </a:ext>
             </a:extLst>
           </p:cNvPr>
@@ -33812,7 +33812,7 @@
           <p:cNvPr id="37" name="s5 row2">
             <a:extLst>
               <a:ext uri="{FF2B5EF4-FFF2-40B4-BE49-F238E27FC236}">
-                <a16:creationId xmlns:a16="http://schemas.microsoft.com/office/drawing/2014/main" id="{05E4B12E-E9C6-D0E3-4483-2F1858771A2A}"/>
+                <a16:creationId xmlns:a16="http://schemas.microsoft.com/office/drawing/2014/main" id="{51C8B526-52E3-307B-5CC2-CD11FDE7F9C9}"/>
               </a:ext>
             </a:extLst>
           </p:cNvPr>
@@ -35060,7 +35060,7 @@
           <p:cNvPr id="56" name="s6 input">
             <a:extLst>
               <a:ext uri="{FF2B5EF4-FFF2-40B4-BE49-F238E27FC236}">
-                <a16:creationId xmlns:a16="http://schemas.microsoft.com/office/drawing/2014/main" id="{66CC15BF-571A-8E80-63F9-3F852064D1A6}"/>
+                <a16:creationId xmlns:a16="http://schemas.microsoft.com/office/drawing/2014/main" id="{CBC85EAE-DA4B-4ACE-2EEF-D6DCBD3D1CF6}"/>
               </a:ext>
             </a:extLst>
           </p:cNvPr>
@@ -35384,7 +35384,7 @@
           <p:cNvPr id="53" name="s6 comp0">
             <a:extLst>
               <a:ext uri="{FF2B5EF4-FFF2-40B4-BE49-F238E27FC236}">
-                <a16:creationId xmlns:a16="http://schemas.microsoft.com/office/drawing/2014/main" id="{959F1862-46A0-E651-AD9B-DCA93618D25B}"/>
+                <a16:creationId xmlns:a16="http://schemas.microsoft.com/office/drawing/2014/main" id="{FE8E09A9-5BCA-62A6-5315-62227B0BCA27}"/>
               </a:ext>
             </a:extLst>
           </p:cNvPr>
@@ -35641,7 +35641,7 @@
           <p:cNvPr id="54" name="s6 comp1">
             <a:extLst>
               <a:ext uri="{FF2B5EF4-FFF2-40B4-BE49-F238E27FC236}">
-                <a16:creationId xmlns:a16="http://schemas.microsoft.com/office/drawing/2014/main" id="{99D83AFF-E1EE-A773-9D67-F53058B80899}"/>
+                <a16:creationId xmlns:a16="http://schemas.microsoft.com/office/drawing/2014/main" id="{B96C5D8A-68DC-8839-9272-A6BBD68CCA4D}"/>
               </a:ext>
             </a:extLst>
           </p:cNvPr>
@@ -35898,7 +35898,7 @@
           <p:cNvPr id="55" name="s6 comp2">
             <a:extLst>
               <a:ext uri="{FF2B5EF4-FFF2-40B4-BE49-F238E27FC236}">
-                <a16:creationId xmlns:a16="http://schemas.microsoft.com/office/drawing/2014/main" id="{637E50F0-4264-D75D-1D62-18AD65F47E3E}"/>
+                <a16:creationId xmlns:a16="http://schemas.microsoft.com/office/drawing/2014/main" id="{652797E7-D1E0-2F74-92C6-FC56DFDA0F8B}"/>
               </a:ext>
             </a:extLst>
           </p:cNvPr>
@@ -36155,7 +36155,7 @@
           <p:cNvPr id="57" name="s6 hood">
             <a:extLst>
               <a:ext uri="{FF2B5EF4-FFF2-40B4-BE49-F238E27FC236}">
-                <a16:creationId xmlns:a16="http://schemas.microsoft.com/office/drawing/2014/main" id="{A143D11E-7323-412E-8185-1C13C79969AC}"/>
+                <a16:creationId xmlns:a16="http://schemas.microsoft.com/office/drawing/2014/main" id="{C5482532-1F90-ECFD-75B6-CAD7E3A1CBFA}"/>
               </a:ext>
             </a:extLst>
           </p:cNvPr>
@@ -37509,7 +37509,7 @@
           <p:cNvPr id="42" name="s7 card">
             <a:extLst>
               <a:ext uri="{FF2B5EF4-FFF2-40B4-BE49-F238E27FC236}">
-                <a16:creationId xmlns:a16="http://schemas.microsoft.com/office/drawing/2014/main" id="{B77DD2EA-5AF6-6B8A-0F86-3AA49CDE5243}"/>
+                <a16:creationId xmlns:a16="http://schemas.microsoft.com/office/drawing/2014/main" id="{C14BDBAA-5BF3-5FC8-973E-CDA6C92F222D}"/>
               </a:ext>
             </a:extLst>
           </p:cNvPr>
@@ -37934,7 +37934,7 @@
           <p:cNvPr id="40" name="s7 tileA">
             <a:extLst>
               <a:ext uri="{FF2B5EF4-FFF2-40B4-BE49-F238E27FC236}">
-                <a16:creationId xmlns:a16="http://schemas.microsoft.com/office/drawing/2014/main" id="{021926BD-B860-742C-C409-3142A1462636}"/>
+                <a16:creationId xmlns:a16="http://schemas.microsoft.com/office/drawing/2014/main" id="{C13551F1-365E-979F-17F3-88187946BFEA}"/>
               </a:ext>
             </a:extLst>
           </p:cNvPr>
@@ -38101,7 +38101,7 @@
           <p:cNvPr id="41" name="s7 tileB">
             <a:extLst>
               <a:ext uri="{FF2B5EF4-FFF2-40B4-BE49-F238E27FC236}">
-                <a16:creationId xmlns:a16="http://schemas.microsoft.com/office/drawing/2014/main" id="{D784AFEA-7184-BDB8-E656-375F20236317}"/>
+                <a16:creationId xmlns:a16="http://schemas.microsoft.com/office/drawing/2014/main" id="{A6F74729-C068-D790-4D98-C66FC70FA462}"/>
               </a:ext>
             </a:extLst>
           </p:cNvPr>
@@ -39566,7 +39566,7 @@
           <p:cNvPr id="240" name="s8 waffleA">
             <a:extLst>
               <a:ext uri="{FF2B5EF4-FFF2-40B4-BE49-F238E27FC236}">
-                <a16:creationId xmlns:a16="http://schemas.microsoft.com/office/drawing/2014/main" id="{9261C4A1-4AD9-7357-AA26-C4E28A6CA3B3}"/>
+                <a16:creationId xmlns:a16="http://schemas.microsoft.com/office/drawing/2014/main" id="{33AE0E95-B1AB-A533-279F-A7AFFCC5BA40}"/>
               </a:ext>
             </a:extLst>
           </p:cNvPr>
@@ -42487,7 +42487,7 @@
           <p:cNvPr id="241" name="s8 numA">
             <a:extLst>
               <a:ext uri="{FF2B5EF4-FFF2-40B4-BE49-F238E27FC236}">
-                <a16:creationId xmlns:a16="http://schemas.microsoft.com/office/drawing/2014/main" id="{AB0617B2-B90A-8469-42BF-69F48D742EF8}"/>
+                <a16:creationId xmlns:a16="http://schemas.microsoft.com/office/drawing/2014/main" id="{1F2DE4EB-8B26-979E-E0D5-CB16DCD9321E}"/>
               </a:ext>
             </a:extLst>
           </p:cNvPr>
@@ -42603,7 +42603,7 @@
           <p:cNvPr id="247" name="s8 random">
             <a:extLst>
               <a:ext uri="{FF2B5EF4-FFF2-40B4-BE49-F238E27FC236}">
-                <a16:creationId xmlns:a16="http://schemas.microsoft.com/office/drawing/2014/main" id="{FB27C283-E61D-845C-B8C2-6C6AE1A4EE4A}"/>
+                <a16:creationId xmlns:a16="http://schemas.microsoft.com/office/drawing/2014/main" id="{A7148869-9D31-ED8B-D191-4217EE80A7FD}"/>
               </a:ext>
             </a:extLst>
           </p:cNvPr>
@@ -42662,7 +42662,7 @@
             <p:cNvPr id="243" name="s8 numB">
               <a:extLst>
                 <a:ext uri="{FF2B5EF4-FFF2-40B4-BE49-F238E27FC236}">
-                  <a16:creationId xmlns:a16="http://schemas.microsoft.com/office/drawing/2014/main" id="{2F840362-F379-1719-3258-A5D06A14C778}"/>
+                  <a16:creationId xmlns:a16="http://schemas.microsoft.com/office/drawing/2014/main" id="{B34D9A96-0F53-B555-7552-75FE6C70EC2D}"/>
                 </a:ext>
               </a:extLst>
             </p:cNvPr>
@@ -42779,7 +42779,7 @@
           <p:cNvPr id="242" name="s8 waffleB">
             <a:extLst>
               <a:ext uri="{FF2B5EF4-FFF2-40B4-BE49-F238E27FC236}">
-                <a16:creationId xmlns:a16="http://schemas.microsoft.com/office/drawing/2014/main" id="{EC04B536-C19B-3A73-DA3F-A8E0E6C69E77}"/>
+                <a16:creationId xmlns:a16="http://schemas.microsoft.com/office/drawing/2014/main" id="{B973D9EC-933F-0117-7E3D-726063E158A2}"/>
               </a:ext>
             </a:extLst>
           </p:cNvPr>
@@ -45794,7 +45794,7 @@
           <p:cNvPr id="244" name="s8 tileA">
             <a:extLst>
               <a:ext uri="{FF2B5EF4-FFF2-40B4-BE49-F238E27FC236}">
-                <a16:creationId xmlns:a16="http://schemas.microsoft.com/office/drawing/2014/main" id="{E14CEEBF-6936-8F08-1B0B-0E6F6019A70B}"/>
+                <a16:creationId xmlns:a16="http://schemas.microsoft.com/office/drawing/2014/main" id="{6B49CC68-EEB1-ED52-BD72-2A63545A0E55}"/>
               </a:ext>
             </a:extLst>
           </p:cNvPr>
@@ -45961,7 +45961,7 @@
           <p:cNvPr id="245" name="s8 tileB">
             <a:extLst>
               <a:ext uri="{FF2B5EF4-FFF2-40B4-BE49-F238E27FC236}">
-                <a16:creationId xmlns:a16="http://schemas.microsoft.com/office/drawing/2014/main" id="{4CDB2A61-8D0B-7BB9-61BC-187577C15092}"/>
+                <a16:creationId xmlns:a16="http://schemas.microsoft.com/office/drawing/2014/main" id="{BFDC3612-6955-F9C5-9856-2BA79E29F373}"/>
               </a:ext>
             </a:extLst>
           </p:cNvPr>
@@ -46128,7 +46128,7 @@
           <p:cNvPr id="246" name="s8 tileC">
             <a:extLst>
               <a:ext uri="{FF2B5EF4-FFF2-40B4-BE49-F238E27FC236}">
-                <a16:creationId xmlns:a16="http://schemas.microsoft.com/office/drawing/2014/main" id="{E36FDF21-75D8-E3E9-4F07-517F5CC73E17}"/>
+                <a16:creationId xmlns:a16="http://schemas.microsoft.com/office/drawing/2014/main" id="{A271DF1D-725C-A096-7B7C-7A087A411437}"/>
               </a:ext>
             </a:extLst>
           </p:cNvPr>
@@ -47607,7 +47607,7 @@
           <p:cNvPr id="37" name="s9 browser">
             <a:extLst>
               <a:ext uri="{FF2B5EF4-FFF2-40B4-BE49-F238E27FC236}">
-                <a16:creationId xmlns:a16="http://schemas.microsoft.com/office/drawing/2014/main" id="{402C3DE4-84CD-232D-DF2B-47AE16FDE9C9}"/>
+                <a16:creationId xmlns:a16="http://schemas.microsoft.com/office/drawing/2014/main" id="{713A6EBC-F463-303E-BFAF-613565513E39}"/>
               </a:ext>
             </a:extLst>
           </p:cNvPr>
@@ -47834,7 +47834,7 @@
           <p:cNvPr id="38" name="s9 live group">
             <a:extLst>
               <a:ext uri="{FF2B5EF4-FFF2-40B4-BE49-F238E27FC236}">
-                <a16:creationId xmlns:a16="http://schemas.microsoft.com/office/drawing/2014/main" id="{B571FEBB-F336-EBDE-6271-FC249CDBA719}"/>
+                <a16:creationId xmlns:a16="http://schemas.microsoft.com/office/drawing/2014/main" id="{30B8AEAA-905B-D700-9231-31EAE63D5A8D}"/>
               </a:ext>
             </a:extLst>
           </p:cNvPr>
@@ -47982,7 +47982,7 @@
           <p:cNvPr id="39" name="s9 result">
             <a:extLst>
               <a:ext uri="{FF2B5EF4-FFF2-40B4-BE49-F238E27FC236}">
-                <a16:creationId xmlns:a16="http://schemas.microsoft.com/office/drawing/2014/main" id="{9C7EED4F-12E9-4A1F-DC20-AF1502081682}"/>
+                <a16:creationId xmlns:a16="http://schemas.microsoft.com/office/drawing/2014/main" id="{6E2D7C13-C66A-A48F-E50E-3C662D2D8D7E}"/>
               </a:ext>
             </a:extLst>
           </p:cNvPr>

</xml_diff>